<commit_message>
Redesign STL upload UI with 3D viewer and split-screen configurator
Replaces the form-based STL upload flow with a Digifabster-style split-screen
layout: interactive 3D preview on the left (react-three-fiber with orbit/zoom,
auto-fit bounds, contact shadows, grid) and configurator + live price panel
on the right (technology/material/color/finish/quantity with live updates).

Homepage PriceCalculator now redirects uploads to /stl-match with file handoff
via router state. /compare-prices uses the same layout in "compare" mode.
Three.js stack is lazy-loaded so landing bundle is unaffected.

Co-Authored-By: Claude Opus 4.7 (1M context) <noreply@anthropic.com>
</commit_message>
<xml_diff>
--- a/SupplyCheck_Partner_Presentation.pptx
+++ b/SupplyCheck_Partner_Presentation.pptx
@@ -5,12 +5,12 @@
     <p:sldMasterId id="2147483648" r:id="rId1"/>
   </p:sldMasterIdLst>
   <p:sldIdLst>
-    <p:sldId id="256" r:id="rId7"/>
-    <p:sldId id="257" r:id="rId8"/>
-    <p:sldId id="258" r:id="rId9"/>
-    <p:sldId id="259" r:id="rId10"/>
+    <p:sldId id="257" r:id="rId2"/>
+    <p:sldId id="260" r:id="rId3"/>
+    <p:sldId id="258" r:id="rId4"/>
+    <p:sldId id="259" r:id="rId5"/>
   </p:sldIdLst>
-  <p:sldSz cx="12191695" cy="6858000" type="screen4x3"/>
+  <p:sldSz cx="12192000" cy="6858000"/>
   <p:notesSz cx="6858000" cy="9144000"/>
   <p:defaultTextStyle>
     <a:defPPr>
@@ -107,6 +107,22 @@
       </a:defRPr>
     </a:lvl9pPr>
   </p:defaultTextStyle>
+  <p:extLst>
+    <p:ext uri="{EFAFB233-063F-42B5-8137-9DF3F51BA10A}">
+      <p15:sldGuideLst xmlns:p15="http://schemas.microsoft.com/office/powerpoint/2012/main">
+        <p15:guide id="1" orient="horz" pos="2160">
+          <p15:clr>
+            <a:srgbClr val="A4A3A4"/>
+          </p15:clr>
+        </p15:guide>
+        <p15:guide id="2" pos="2880">
+          <p15:clr>
+            <a:srgbClr val="A4A3A4"/>
+          </p15:clr>
+        </p15:guide>
+      </p15:sldGuideLst>
+    </p:ext>
+  </p:extLst>
 </p:presentation>
 </file>
 
@@ -148,10 +164,9 @@
           <a:lstStyle/>
           <a:p>
             <a:r>
-              <a:rPr lang="en-US" smtClean="0"/>
+              <a:rPr lang="en-US"/>
               <a:t>Click to edit Master title style</a:t>
             </a:r>
-            <a:endParaRPr lang="en-US"/>
           </a:p>
         </p:txBody>
       </p:sp>
@@ -267,10 +282,9 @@
           </a:lstStyle>
           <a:p>
             <a:r>
-              <a:rPr lang="en-US" smtClean="0"/>
+              <a:rPr lang="en-US"/>
               <a:t>Click to edit Master subtitle style</a:t>
             </a:r>
-            <a:endParaRPr lang="en-US"/>
           </a:p>
         </p:txBody>
       </p:sp>
@@ -291,7 +305,7 @@
           <a:p>
             <a:fld id="{5BCAD085-E8A6-8845-BD4E-CB4CCA059FC4}" type="datetimeFigureOut">
               <a:rPr lang="en-US" smtClean="0"/>
-              <a:t>1/27/13</a:t>
+              <a:t>4/21/26</a:t>
             </a:fld>
             <a:endParaRPr lang="en-US"/>
           </a:p>
@@ -333,7 +347,7 @@
           <a:p>
             <a:fld id="{C1FF6DA9-008F-8B48-92A6-B652298478BF}" type="slidenum">
               <a:rPr lang="en-US" smtClean="0"/>
-              <a:t>‹#›</a:t>
+              <a:t>‹nr.›</a:t>
             </a:fld>
             <a:endParaRPr lang="en-US"/>
           </a:p>
@@ -385,10 +399,9 @@
           <a:lstStyle/>
           <a:p>
             <a:r>
-              <a:rPr lang="en-US" smtClean="0"/>
+              <a:rPr lang="en-US"/>
               <a:t>Click to edit Master title style</a:t>
             </a:r>
-            <a:endParaRPr lang="en-US"/>
           </a:p>
         </p:txBody>
       </p:sp>
@@ -409,38 +422,37 @@
           <a:p>
             <a:pPr lvl="0"/>
             <a:r>
-              <a:rPr lang="en-US" smtClean="0"/>
+              <a:rPr lang="en-US"/>
               <a:t>Click to edit Master text styles</a:t>
             </a:r>
           </a:p>
           <a:p>
             <a:pPr lvl="1"/>
             <a:r>
-              <a:rPr lang="en-US" smtClean="0"/>
+              <a:rPr lang="en-US"/>
               <a:t>Second level</a:t>
             </a:r>
           </a:p>
           <a:p>
             <a:pPr lvl="2"/>
             <a:r>
-              <a:rPr lang="en-US" smtClean="0"/>
+              <a:rPr lang="en-US"/>
               <a:t>Third level</a:t>
             </a:r>
           </a:p>
           <a:p>
             <a:pPr lvl="3"/>
             <a:r>
-              <a:rPr lang="en-US" smtClean="0"/>
+              <a:rPr lang="en-US"/>
               <a:t>Fourth level</a:t>
             </a:r>
           </a:p>
           <a:p>
             <a:pPr lvl="4"/>
             <a:r>
-              <a:rPr lang="en-US" smtClean="0"/>
+              <a:rPr lang="en-US"/>
               <a:t>Fifth level</a:t>
             </a:r>
-            <a:endParaRPr lang="en-US"/>
           </a:p>
         </p:txBody>
       </p:sp>
@@ -461,7 +473,7 @@
           <a:p>
             <a:fld id="{5BCAD085-E8A6-8845-BD4E-CB4CCA059FC4}" type="datetimeFigureOut">
               <a:rPr lang="en-US" smtClean="0"/>
-              <a:t>1/27/13</a:t>
+              <a:t>4/21/26</a:t>
             </a:fld>
             <a:endParaRPr lang="en-US"/>
           </a:p>
@@ -503,7 +515,7 @@
           <a:p>
             <a:fld id="{C1FF6DA9-008F-8B48-92A6-B652298478BF}" type="slidenum">
               <a:rPr lang="en-US" smtClean="0"/>
-              <a:t>‹#›</a:t>
+              <a:t>‹nr.›</a:t>
             </a:fld>
             <a:endParaRPr lang="en-US"/>
           </a:p>
@@ -560,10 +572,9 @@
           <a:lstStyle/>
           <a:p>
             <a:r>
-              <a:rPr lang="en-US" smtClean="0"/>
+              <a:rPr lang="en-US"/>
               <a:t>Click to edit Master title style</a:t>
             </a:r>
-            <a:endParaRPr lang="en-US"/>
           </a:p>
         </p:txBody>
       </p:sp>
@@ -589,38 +600,37 @@
           <a:p>
             <a:pPr lvl="0"/>
             <a:r>
-              <a:rPr lang="en-US" smtClean="0"/>
+              <a:rPr lang="en-US"/>
               <a:t>Click to edit Master text styles</a:t>
             </a:r>
           </a:p>
           <a:p>
             <a:pPr lvl="1"/>
             <a:r>
-              <a:rPr lang="en-US" smtClean="0"/>
+              <a:rPr lang="en-US"/>
               <a:t>Second level</a:t>
             </a:r>
           </a:p>
           <a:p>
             <a:pPr lvl="2"/>
             <a:r>
-              <a:rPr lang="en-US" smtClean="0"/>
+              <a:rPr lang="en-US"/>
               <a:t>Third level</a:t>
             </a:r>
           </a:p>
           <a:p>
             <a:pPr lvl="3"/>
             <a:r>
-              <a:rPr lang="en-US" smtClean="0"/>
+              <a:rPr lang="en-US"/>
               <a:t>Fourth level</a:t>
             </a:r>
           </a:p>
           <a:p>
             <a:pPr lvl="4"/>
             <a:r>
-              <a:rPr lang="en-US" smtClean="0"/>
+              <a:rPr lang="en-US"/>
               <a:t>Fifth level</a:t>
             </a:r>
-            <a:endParaRPr lang="en-US"/>
           </a:p>
         </p:txBody>
       </p:sp>
@@ -641,7 +651,7 @@
           <a:p>
             <a:fld id="{5BCAD085-E8A6-8845-BD4E-CB4CCA059FC4}" type="datetimeFigureOut">
               <a:rPr lang="en-US" smtClean="0"/>
-              <a:t>1/27/13</a:t>
+              <a:t>4/21/26</a:t>
             </a:fld>
             <a:endParaRPr lang="en-US"/>
           </a:p>
@@ -683,7 +693,7 @@
           <a:p>
             <a:fld id="{C1FF6DA9-008F-8B48-92A6-B652298478BF}" type="slidenum">
               <a:rPr lang="en-US" smtClean="0"/>
-              <a:t>‹#›</a:t>
+              <a:t>‹nr.›</a:t>
             </a:fld>
             <a:endParaRPr lang="en-US"/>
           </a:p>
@@ -735,10 +745,9 @@
           <a:lstStyle/>
           <a:p>
             <a:r>
-              <a:rPr lang="en-US" smtClean="0"/>
+              <a:rPr lang="en-US"/>
               <a:t>Click to edit Master title style</a:t>
             </a:r>
-            <a:endParaRPr lang="en-US"/>
           </a:p>
         </p:txBody>
       </p:sp>
@@ -759,38 +768,37 @@
           <a:p>
             <a:pPr lvl="0"/>
             <a:r>
-              <a:rPr lang="en-US" smtClean="0"/>
+              <a:rPr lang="en-US"/>
               <a:t>Click to edit Master text styles</a:t>
             </a:r>
           </a:p>
           <a:p>
             <a:pPr lvl="1"/>
             <a:r>
-              <a:rPr lang="en-US" smtClean="0"/>
+              <a:rPr lang="en-US"/>
               <a:t>Second level</a:t>
             </a:r>
           </a:p>
           <a:p>
             <a:pPr lvl="2"/>
             <a:r>
-              <a:rPr lang="en-US" smtClean="0"/>
+              <a:rPr lang="en-US"/>
               <a:t>Third level</a:t>
             </a:r>
           </a:p>
           <a:p>
             <a:pPr lvl="3"/>
             <a:r>
-              <a:rPr lang="en-US" smtClean="0"/>
+              <a:rPr lang="en-US"/>
               <a:t>Fourth level</a:t>
             </a:r>
           </a:p>
           <a:p>
             <a:pPr lvl="4"/>
             <a:r>
-              <a:rPr lang="en-US" smtClean="0"/>
+              <a:rPr lang="en-US"/>
               <a:t>Fifth level</a:t>
             </a:r>
-            <a:endParaRPr lang="en-US"/>
           </a:p>
         </p:txBody>
       </p:sp>
@@ -811,7 +819,7 @@
           <a:p>
             <a:fld id="{5BCAD085-E8A6-8845-BD4E-CB4CCA059FC4}" type="datetimeFigureOut">
               <a:rPr lang="en-US" smtClean="0"/>
-              <a:t>1/27/13</a:t>
+              <a:t>4/21/26</a:t>
             </a:fld>
             <a:endParaRPr lang="en-US"/>
           </a:p>
@@ -853,7 +861,7 @@
           <a:p>
             <a:fld id="{C1FF6DA9-008F-8B48-92A6-B652298478BF}" type="slidenum">
               <a:rPr lang="en-US" smtClean="0"/>
-              <a:t>‹#›</a:t>
+              <a:t>‹nr.›</a:t>
             </a:fld>
             <a:endParaRPr lang="en-US"/>
           </a:p>
@@ -914,10 +922,9 @@
           </a:lstStyle>
           <a:p>
             <a:r>
-              <a:rPr lang="en-US" smtClean="0"/>
+              <a:rPr lang="en-US"/>
               <a:t>Click to edit Master title style</a:t>
             </a:r>
-            <a:endParaRPr lang="en-US"/>
           </a:p>
         </p:txBody>
       </p:sp>
@@ -1034,7 +1041,7 @@
           <a:p>
             <a:pPr lvl="0"/>
             <a:r>
-              <a:rPr lang="en-US" smtClean="0"/>
+              <a:rPr lang="en-US"/>
               <a:t>Click to edit Master text styles</a:t>
             </a:r>
           </a:p>
@@ -1057,7 +1064,7 @@
           <a:p>
             <a:fld id="{5BCAD085-E8A6-8845-BD4E-CB4CCA059FC4}" type="datetimeFigureOut">
               <a:rPr lang="en-US" smtClean="0"/>
-              <a:t>1/27/13</a:t>
+              <a:t>4/21/26</a:t>
             </a:fld>
             <a:endParaRPr lang="en-US"/>
           </a:p>
@@ -1099,7 +1106,7 @@
           <a:p>
             <a:fld id="{C1FF6DA9-008F-8B48-92A6-B652298478BF}" type="slidenum">
               <a:rPr lang="en-US" smtClean="0"/>
-              <a:t>‹#›</a:t>
+              <a:t>‹nr.›</a:t>
             </a:fld>
             <a:endParaRPr lang="en-US"/>
           </a:p>
@@ -1151,10 +1158,9 @@
           <a:lstStyle/>
           <a:p>
             <a:r>
-              <a:rPr lang="en-US" smtClean="0"/>
+              <a:rPr lang="en-US"/>
               <a:t>Click to edit Master title style</a:t>
             </a:r>
-            <a:endParaRPr lang="en-US"/>
           </a:p>
         </p:txBody>
       </p:sp>
@@ -1208,38 +1214,37 @@
           <a:p>
             <a:pPr lvl="0"/>
             <a:r>
-              <a:rPr lang="en-US" smtClean="0"/>
+              <a:rPr lang="en-US"/>
               <a:t>Click to edit Master text styles</a:t>
             </a:r>
           </a:p>
           <a:p>
             <a:pPr lvl="1"/>
             <a:r>
-              <a:rPr lang="en-US" smtClean="0"/>
+              <a:rPr lang="en-US"/>
               <a:t>Second level</a:t>
             </a:r>
           </a:p>
           <a:p>
             <a:pPr lvl="2"/>
             <a:r>
-              <a:rPr lang="en-US" smtClean="0"/>
+              <a:rPr lang="en-US"/>
               <a:t>Third level</a:t>
             </a:r>
           </a:p>
           <a:p>
             <a:pPr lvl="3"/>
             <a:r>
-              <a:rPr lang="en-US" smtClean="0"/>
+              <a:rPr lang="en-US"/>
               <a:t>Fourth level</a:t>
             </a:r>
           </a:p>
           <a:p>
             <a:pPr lvl="4"/>
             <a:r>
-              <a:rPr lang="en-US" smtClean="0"/>
+              <a:rPr lang="en-US"/>
               <a:t>Fifth level</a:t>
             </a:r>
-            <a:endParaRPr lang="en-US"/>
           </a:p>
         </p:txBody>
       </p:sp>
@@ -1293,38 +1298,37 @@
           <a:p>
             <a:pPr lvl="0"/>
             <a:r>
-              <a:rPr lang="en-US" smtClean="0"/>
+              <a:rPr lang="en-US"/>
               <a:t>Click to edit Master text styles</a:t>
             </a:r>
           </a:p>
           <a:p>
             <a:pPr lvl="1"/>
             <a:r>
-              <a:rPr lang="en-US" smtClean="0"/>
+              <a:rPr lang="en-US"/>
               <a:t>Second level</a:t>
             </a:r>
           </a:p>
           <a:p>
             <a:pPr lvl="2"/>
             <a:r>
-              <a:rPr lang="en-US" smtClean="0"/>
+              <a:rPr lang="en-US"/>
               <a:t>Third level</a:t>
             </a:r>
           </a:p>
           <a:p>
             <a:pPr lvl="3"/>
             <a:r>
-              <a:rPr lang="en-US" smtClean="0"/>
+              <a:rPr lang="en-US"/>
               <a:t>Fourth level</a:t>
             </a:r>
           </a:p>
           <a:p>
             <a:pPr lvl="4"/>
             <a:r>
-              <a:rPr lang="en-US" smtClean="0"/>
+              <a:rPr lang="en-US"/>
               <a:t>Fifth level</a:t>
             </a:r>
-            <a:endParaRPr lang="en-US"/>
           </a:p>
         </p:txBody>
       </p:sp>
@@ -1345,7 +1349,7 @@
           <a:p>
             <a:fld id="{5BCAD085-E8A6-8845-BD4E-CB4CCA059FC4}" type="datetimeFigureOut">
               <a:rPr lang="en-US" smtClean="0"/>
-              <a:t>1/27/13</a:t>
+              <a:t>4/21/26</a:t>
             </a:fld>
             <a:endParaRPr lang="en-US"/>
           </a:p>
@@ -1387,7 +1391,7 @@
           <a:p>
             <a:fld id="{C1FF6DA9-008F-8B48-92A6-B652298478BF}" type="slidenum">
               <a:rPr lang="en-US" smtClean="0"/>
-              <a:t>‹#›</a:t>
+              <a:t>‹nr.›</a:t>
             </a:fld>
             <a:endParaRPr lang="en-US"/>
           </a:p>
@@ -1443,10 +1447,9 @@
           </a:lstStyle>
           <a:p>
             <a:r>
-              <a:rPr lang="en-US" smtClean="0"/>
+              <a:rPr lang="en-US"/>
               <a:t>Click to edit Master title style</a:t>
             </a:r>
-            <a:endParaRPr lang="en-US"/>
           </a:p>
         </p:txBody>
       </p:sp>
@@ -1509,7 +1512,7 @@
           <a:p>
             <a:pPr lvl="0"/>
             <a:r>
-              <a:rPr lang="en-US" smtClean="0"/>
+              <a:rPr lang="en-US"/>
               <a:t>Click to edit Master text styles</a:t>
             </a:r>
           </a:p>
@@ -1565,38 +1568,37 @@
           <a:p>
             <a:pPr lvl="0"/>
             <a:r>
-              <a:rPr lang="en-US" smtClean="0"/>
+              <a:rPr lang="en-US"/>
               <a:t>Click to edit Master text styles</a:t>
             </a:r>
           </a:p>
           <a:p>
             <a:pPr lvl="1"/>
             <a:r>
-              <a:rPr lang="en-US" smtClean="0"/>
+              <a:rPr lang="en-US"/>
               <a:t>Second level</a:t>
             </a:r>
           </a:p>
           <a:p>
             <a:pPr lvl="2"/>
             <a:r>
-              <a:rPr lang="en-US" smtClean="0"/>
+              <a:rPr lang="en-US"/>
               <a:t>Third level</a:t>
             </a:r>
           </a:p>
           <a:p>
             <a:pPr lvl="3"/>
             <a:r>
-              <a:rPr lang="en-US" smtClean="0"/>
+              <a:rPr lang="en-US"/>
               <a:t>Fourth level</a:t>
             </a:r>
           </a:p>
           <a:p>
             <a:pPr lvl="4"/>
             <a:r>
-              <a:rPr lang="en-US" smtClean="0"/>
+              <a:rPr lang="en-US"/>
               <a:t>Fifth level</a:t>
             </a:r>
-            <a:endParaRPr lang="en-US"/>
           </a:p>
         </p:txBody>
       </p:sp>
@@ -1659,7 +1661,7 @@
           <a:p>
             <a:pPr lvl="0"/>
             <a:r>
-              <a:rPr lang="en-US" smtClean="0"/>
+              <a:rPr lang="en-US"/>
               <a:t>Click to edit Master text styles</a:t>
             </a:r>
           </a:p>
@@ -1715,38 +1717,37 @@
           <a:p>
             <a:pPr lvl="0"/>
             <a:r>
-              <a:rPr lang="en-US" smtClean="0"/>
+              <a:rPr lang="en-US"/>
               <a:t>Click to edit Master text styles</a:t>
             </a:r>
           </a:p>
           <a:p>
             <a:pPr lvl="1"/>
             <a:r>
-              <a:rPr lang="en-US" smtClean="0"/>
+              <a:rPr lang="en-US"/>
               <a:t>Second level</a:t>
             </a:r>
           </a:p>
           <a:p>
             <a:pPr lvl="2"/>
             <a:r>
-              <a:rPr lang="en-US" smtClean="0"/>
+              <a:rPr lang="en-US"/>
               <a:t>Third level</a:t>
             </a:r>
           </a:p>
           <a:p>
             <a:pPr lvl="3"/>
             <a:r>
-              <a:rPr lang="en-US" smtClean="0"/>
+              <a:rPr lang="en-US"/>
               <a:t>Fourth level</a:t>
             </a:r>
           </a:p>
           <a:p>
             <a:pPr lvl="4"/>
             <a:r>
-              <a:rPr lang="en-US" smtClean="0"/>
+              <a:rPr lang="en-US"/>
               <a:t>Fifth level</a:t>
             </a:r>
-            <a:endParaRPr lang="en-US"/>
           </a:p>
         </p:txBody>
       </p:sp>
@@ -1767,7 +1768,7 @@
           <a:p>
             <a:fld id="{5BCAD085-E8A6-8845-BD4E-CB4CCA059FC4}" type="datetimeFigureOut">
               <a:rPr lang="en-US" smtClean="0"/>
-              <a:t>1/27/13</a:t>
+              <a:t>4/21/26</a:t>
             </a:fld>
             <a:endParaRPr lang="en-US"/>
           </a:p>
@@ -1809,7 +1810,7 @@
           <a:p>
             <a:fld id="{C1FF6DA9-008F-8B48-92A6-B652298478BF}" type="slidenum">
               <a:rPr lang="en-US" smtClean="0"/>
-              <a:t>‹#›</a:t>
+              <a:t>‹nr.›</a:t>
             </a:fld>
             <a:endParaRPr lang="en-US"/>
           </a:p>
@@ -1861,10 +1862,9 @@
           <a:lstStyle/>
           <a:p>
             <a:r>
-              <a:rPr lang="en-US" smtClean="0"/>
+              <a:rPr lang="en-US"/>
               <a:t>Click to edit Master title style</a:t>
             </a:r>
-            <a:endParaRPr lang="en-US"/>
           </a:p>
         </p:txBody>
       </p:sp>
@@ -1885,7 +1885,7 @@
           <a:p>
             <a:fld id="{5BCAD085-E8A6-8845-BD4E-CB4CCA059FC4}" type="datetimeFigureOut">
               <a:rPr lang="en-US" smtClean="0"/>
-              <a:t>1/27/13</a:t>
+              <a:t>4/21/26</a:t>
             </a:fld>
             <a:endParaRPr lang="en-US"/>
           </a:p>
@@ -1927,7 +1927,7 @@
           <a:p>
             <a:fld id="{C1FF6DA9-008F-8B48-92A6-B652298478BF}" type="slidenum">
               <a:rPr lang="en-US" smtClean="0"/>
-              <a:t>‹#›</a:t>
+              <a:t>‹nr.›</a:t>
             </a:fld>
             <a:endParaRPr lang="en-US"/>
           </a:p>
@@ -1980,7 +1980,7 @@
           <a:p>
             <a:fld id="{5BCAD085-E8A6-8845-BD4E-CB4CCA059FC4}" type="datetimeFigureOut">
               <a:rPr lang="en-US" smtClean="0"/>
-              <a:t>1/27/13</a:t>
+              <a:t>4/21/26</a:t>
             </a:fld>
             <a:endParaRPr lang="en-US"/>
           </a:p>
@@ -2022,7 +2022,7 @@
           <a:p>
             <a:fld id="{C1FF6DA9-008F-8B48-92A6-B652298478BF}" type="slidenum">
               <a:rPr lang="en-US" smtClean="0"/>
-              <a:t>‹#›</a:t>
+              <a:t>‹nr.›</a:t>
             </a:fld>
             <a:endParaRPr lang="en-US"/>
           </a:p>
@@ -2083,10 +2083,9 @@
           </a:lstStyle>
           <a:p>
             <a:r>
-              <a:rPr lang="en-US" smtClean="0"/>
+              <a:rPr lang="en-US"/>
               <a:t>Click to edit Master title style</a:t>
             </a:r>
-            <a:endParaRPr lang="en-US"/>
           </a:p>
         </p:txBody>
       </p:sp>
@@ -2140,38 +2139,37 @@
           <a:p>
             <a:pPr lvl="0"/>
             <a:r>
-              <a:rPr lang="en-US" smtClean="0"/>
+              <a:rPr lang="en-US"/>
               <a:t>Click to edit Master text styles</a:t>
             </a:r>
           </a:p>
           <a:p>
             <a:pPr lvl="1"/>
             <a:r>
-              <a:rPr lang="en-US" smtClean="0"/>
+              <a:rPr lang="en-US"/>
               <a:t>Second level</a:t>
             </a:r>
           </a:p>
           <a:p>
             <a:pPr lvl="2"/>
             <a:r>
-              <a:rPr lang="en-US" smtClean="0"/>
+              <a:rPr lang="en-US"/>
               <a:t>Third level</a:t>
             </a:r>
           </a:p>
           <a:p>
             <a:pPr lvl="3"/>
             <a:r>
-              <a:rPr lang="en-US" smtClean="0"/>
+              <a:rPr lang="en-US"/>
               <a:t>Fourth level</a:t>
             </a:r>
           </a:p>
           <a:p>
             <a:pPr lvl="4"/>
             <a:r>
-              <a:rPr lang="en-US" smtClean="0"/>
+              <a:rPr lang="en-US"/>
               <a:t>Fifth level</a:t>
             </a:r>
-            <a:endParaRPr lang="en-US"/>
           </a:p>
         </p:txBody>
       </p:sp>
@@ -2234,7 +2232,7 @@
           <a:p>
             <a:pPr lvl="0"/>
             <a:r>
-              <a:rPr lang="en-US" smtClean="0"/>
+              <a:rPr lang="en-US"/>
               <a:t>Click to edit Master text styles</a:t>
             </a:r>
           </a:p>
@@ -2257,7 +2255,7 @@
           <a:p>
             <a:fld id="{5BCAD085-E8A6-8845-BD4E-CB4CCA059FC4}" type="datetimeFigureOut">
               <a:rPr lang="en-US" smtClean="0"/>
-              <a:t>1/27/13</a:t>
+              <a:t>4/21/26</a:t>
             </a:fld>
             <a:endParaRPr lang="en-US"/>
           </a:p>
@@ -2299,7 +2297,7 @@
           <a:p>
             <a:fld id="{C1FF6DA9-008F-8B48-92A6-B652298478BF}" type="slidenum">
               <a:rPr lang="en-US" smtClean="0"/>
-              <a:t>‹#›</a:t>
+              <a:t>‹nr.›</a:t>
             </a:fld>
             <a:endParaRPr lang="en-US"/>
           </a:p>
@@ -2360,10 +2358,9 @@
           </a:lstStyle>
           <a:p>
             <a:r>
-              <a:rPr lang="en-US" smtClean="0"/>
+              <a:rPr lang="en-US"/>
               <a:t>Click to edit Master title style</a:t>
             </a:r>
-            <a:endParaRPr lang="en-US"/>
           </a:p>
         </p:txBody>
       </p:sp>
@@ -2487,7 +2484,7 @@
           <a:p>
             <a:pPr lvl="0"/>
             <a:r>
-              <a:rPr lang="en-US" smtClean="0"/>
+              <a:rPr lang="en-US"/>
               <a:t>Click to edit Master text styles</a:t>
             </a:r>
           </a:p>
@@ -2510,7 +2507,7 @@
           <a:p>
             <a:fld id="{5BCAD085-E8A6-8845-BD4E-CB4CCA059FC4}" type="datetimeFigureOut">
               <a:rPr lang="en-US" smtClean="0"/>
-              <a:t>1/27/13</a:t>
+              <a:t>4/21/26</a:t>
             </a:fld>
             <a:endParaRPr lang="en-US"/>
           </a:p>
@@ -2552,7 +2549,7 @@
           <a:p>
             <a:fld id="{C1FF6DA9-008F-8B48-92A6-B652298478BF}" type="slidenum">
               <a:rPr lang="en-US" smtClean="0"/>
-              <a:t>‹#›</a:t>
+              <a:t>‹nr.›</a:t>
             </a:fld>
             <a:endParaRPr lang="en-US"/>
           </a:p>
@@ -2619,10 +2616,9 @@
           <a:lstStyle/>
           <a:p>
             <a:r>
-              <a:rPr lang="en-US" smtClean="0"/>
+              <a:rPr lang="en-US"/>
               <a:t>Click to edit Master title style</a:t>
             </a:r>
-            <a:endParaRPr lang="en-US"/>
           </a:p>
         </p:txBody>
       </p:sp>
@@ -2653,38 +2649,37 @@
           <a:p>
             <a:pPr lvl="0"/>
             <a:r>
-              <a:rPr lang="en-US" smtClean="0"/>
+              <a:rPr lang="en-US"/>
               <a:t>Click to edit Master text styles</a:t>
             </a:r>
           </a:p>
           <a:p>
             <a:pPr lvl="1"/>
             <a:r>
-              <a:rPr lang="en-US" smtClean="0"/>
+              <a:rPr lang="en-US"/>
               <a:t>Second level</a:t>
             </a:r>
           </a:p>
           <a:p>
             <a:pPr lvl="2"/>
             <a:r>
-              <a:rPr lang="en-US" smtClean="0"/>
+              <a:rPr lang="en-US"/>
               <a:t>Third level</a:t>
             </a:r>
           </a:p>
           <a:p>
             <a:pPr lvl="3"/>
             <a:r>
-              <a:rPr lang="en-US" smtClean="0"/>
+              <a:rPr lang="en-US"/>
               <a:t>Fourth level</a:t>
             </a:r>
           </a:p>
           <a:p>
             <a:pPr lvl="4"/>
             <a:r>
-              <a:rPr lang="en-US" smtClean="0"/>
+              <a:rPr lang="en-US"/>
               <a:t>Fifth level</a:t>
             </a:r>
-            <a:endParaRPr lang="en-US"/>
           </a:p>
         </p:txBody>
       </p:sp>
@@ -2723,7 +2718,7 @@
           <a:p>
             <a:fld id="{5BCAD085-E8A6-8845-BD4E-CB4CCA059FC4}" type="datetimeFigureOut">
               <a:rPr lang="en-US" smtClean="0"/>
-              <a:t>1/27/13</a:t>
+              <a:t>4/21/26</a:t>
             </a:fld>
             <a:endParaRPr lang="en-US"/>
           </a:p>
@@ -2801,7 +2796,7 @@
           <a:p>
             <a:fld id="{C1FF6DA9-008F-8B48-92A6-B652298478BF}" type="slidenum">
               <a:rPr lang="en-US" smtClean="0"/>
-              <a:t>‹#›</a:t>
+              <a:t>‹nr.›</a:t>
             </a:fld>
             <a:endParaRPr lang="en-US"/>
           </a:p>
@@ -3082,7 +3077,7 @@
 </file>
 
 <file path=ppt/slides/slide1.xml><?xml version="1.0" encoding="utf-8"?>
-<p:sld xmlns:a="http://schemas.openxmlformats.org/drawingml/2006/main" xmlns:p="http://schemas.openxmlformats.org/presentationml/2006/main" xmlns:r="http://schemas.openxmlformats.org/officeDocument/2006/relationships">
+<p:sld xmlns:a="http://schemas.openxmlformats.org/drawingml/2006/main" xmlns:r="http://schemas.openxmlformats.org/officeDocument/2006/relationships" xmlns:p="http://schemas.openxmlformats.org/presentationml/2006/main">
   <p:cSld>
     <p:spTree>
       <p:nvGrpSpPr>
@@ -3090,7 +3085,14 @@
         <p:cNvGrpSpPr/>
         <p:nvPr/>
       </p:nvGrpSpPr>
-      <p:grpSpPr/>
+      <p:grpSpPr>
+        <a:xfrm>
+          <a:off x="0" y="0"/>
+          <a:ext cx="0" cy="0"/>
+          <a:chOff x="0" y="0"/>
+          <a:chExt cx="0" cy="0"/>
+        </a:xfrm>
+      </p:grpSpPr>
       <p:sp>
         <p:nvSpPr>
           <p:cNvPr id="2" name="Rectangle 1"/>
@@ -3099,14 +3101,14 @@
         </p:nvSpPr>
         <p:spPr>
           <a:xfrm>
-            <a:off x="0" y="0"/>
-            <a:ext cx="8686800" cy="6858000"/>
+            <a:off x="0" y="1280160"/>
+            <a:ext cx="12191695" cy="5577840"/>
           </a:xfrm>
           <a:prstGeom prst="rect">
             <a:avLst/>
           </a:prstGeom>
           <a:solidFill>
-            <a:srgbClr val="F2F2F2"/>
+            <a:srgbClr val="FFFFFF"/>
           </a:solidFill>
           <a:ln>
             <a:noFill/>
@@ -3131,6 +3133,7 @@
           <a:lstStyle/>
           <a:p>
             <a:pPr algn="ctr"/>
+            <a:endParaRPr/>
           </a:p>
         </p:txBody>
       </p:sp>
@@ -3142,8 +3145,8 @@
         </p:nvSpPr>
         <p:spPr>
           <a:xfrm>
-            <a:off x="8686800" y="0"/>
-            <a:ext cx="3504895" cy="6858000"/>
+            <a:off x="0" y="0"/>
+            <a:ext cx="12191695" cy="1280160"/>
           </a:xfrm>
           <a:prstGeom prst="rect">
             <a:avLst/>
@@ -3174,12 +3177,129 @@
           <a:lstStyle/>
           <a:p>
             <a:pPr algn="ctr"/>
+            <a:endParaRPr/>
+          </a:p>
+        </p:txBody>
+      </p:sp>
+      <p:sp>
+        <p:nvSpPr>
+          <p:cNvPr id="4" name="TextBox 3"/>
+          <p:cNvSpPr txBox="1"/>
+          <p:nvPr/>
+        </p:nvSpPr>
+        <p:spPr>
+          <a:xfrm>
+            <a:off x="457200" y="228600"/>
+            <a:ext cx="9144000" cy="822960"/>
+          </a:xfrm>
+          <a:prstGeom prst="rect">
+            <a:avLst/>
+          </a:prstGeom>
+          <a:noFill/>
+        </p:spPr>
+        <p:txBody>
+          <a:bodyPr wrap="none">
+            <a:spAutoFit/>
+          </a:bodyPr>
+          <a:lstStyle/>
+          <a:p>
+            <a:pPr>
+              <a:defRPr sz="3600" b="1">
+                <a:solidFill>
+                  <a:srgbClr val="FFFFFF"/>
+                </a:solidFill>
+                <a:latin typeface="Georgia"/>
+              </a:defRPr>
+            </a:pPr>
+            <a:r>
+              <a:t>What is SupplyCheck?</a:t>
+            </a:r>
+          </a:p>
+        </p:txBody>
+      </p:sp>
+      <p:sp>
+        <p:nvSpPr>
+          <p:cNvPr id="5" name="Rectangle 4"/>
+          <p:cNvSpPr/>
+          <p:nvPr/>
+        </p:nvSpPr>
+        <p:spPr>
+          <a:xfrm>
+            <a:off x="11277295" y="0"/>
+            <a:ext cx="914400" cy="1280160"/>
+          </a:xfrm>
+          <a:prstGeom prst="rect">
+            <a:avLst/>
+          </a:prstGeom>
+          <a:solidFill>
+            <a:srgbClr val="6B8F3C"/>
+          </a:solidFill>
+          <a:ln>
+            <a:noFill/>
+          </a:ln>
+        </p:spPr>
+        <p:style>
+          <a:lnRef idx="1">
+            <a:schemeClr val="accent1"/>
+          </a:lnRef>
+          <a:fillRef idx="3">
+            <a:schemeClr val="accent1"/>
+          </a:fillRef>
+          <a:effectRef idx="2">
+            <a:schemeClr val="accent1"/>
+          </a:effectRef>
+          <a:fontRef idx="minor">
+            <a:schemeClr val="lt1"/>
+          </a:fontRef>
+        </p:style>
+        <p:txBody>
+          <a:bodyPr rtlCol="0" anchor="ctr"/>
+          <a:lstStyle/>
+          <a:p>
+            <a:pPr algn="ctr"/>
+            <a:endParaRPr/>
+          </a:p>
+        </p:txBody>
+      </p:sp>
+      <p:sp>
+        <p:nvSpPr>
+          <p:cNvPr id="6" name="TextBox 5"/>
+          <p:cNvSpPr txBox="1"/>
+          <p:nvPr/>
+        </p:nvSpPr>
+        <p:spPr>
+          <a:xfrm>
+            <a:off x="11277295" y="228600"/>
+            <a:ext cx="914400" cy="822960"/>
+          </a:xfrm>
+          <a:prstGeom prst="rect">
+            <a:avLst/>
+          </a:prstGeom>
+          <a:noFill/>
+        </p:spPr>
+        <p:txBody>
+          <a:bodyPr wrap="none">
+            <a:spAutoFit/>
+          </a:bodyPr>
+          <a:lstStyle/>
+          <a:p>
+            <a:pPr algn="ctr">
+              <a:defRPr sz="3200" b="1">
+                <a:solidFill>
+                  <a:srgbClr val="FFFFFF"/>
+                </a:solidFill>
+                <a:latin typeface="Georgia"/>
+              </a:defRPr>
+            </a:pPr>
+            <a:r>
+              <a:t>1</a:t>
+            </a:r>
           </a:p>
         </p:txBody>
       </p:sp>
       <p:pic>
         <p:nvPicPr>
-          <p:cNvPr id="4" name="Picture 3" descr="amsupplycheck-logo-new.png"/>
+          <p:cNvPr id="7" name="Picture 6" descr="amsupplycheck-logo-white.png"/>
           <p:cNvPicPr>
             <a:picLocks noChangeAspect="1"/>
           </p:cNvPicPr>
@@ -3193,8 +3313,8 @@
         </p:blipFill>
         <p:spPr>
           <a:xfrm>
-            <a:off x="914400" y="1645920"/>
-            <a:ext cx="6400800" cy="4267200"/>
+            <a:off x="8686800" y="137160"/>
+            <a:ext cx="617220" cy="411480"/>
           </a:xfrm>
           <a:prstGeom prst="rect">
             <a:avLst/>
@@ -3203,14 +3323,14 @@
       </p:pic>
       <p:sp>
         <p:nvSpPr>
-          <p:cNvPr id="5" name="TextBox 4"/>
+          <p:cNvPr id="8" name="TextBox 7"/>
           <p:cNvSpPr txBox="1"/>
           <p:nvPr/>
         </p:nvSpPr>
         <p:spPr>
           <a:xfrm>
-            <a:off x="1371600" y="3474720"/>
-            <a:ext cx="6400800" cy="1097280"/>
+            <a:off x="731520" y="1645920"/>
+            <a:ext cx="10058400" cy="731520"/>
           </a:xfrm>
           <a:prstGeom prst="rect">
             <a:avLst/>
@@ -3223,59 +3343,585 @@
           </a:bodyPr>
           <a:lstStyle/>
           <a:p>
-            <a:pPr>
-              <a:defRPr sz="3200" b="1">
+            <a:r>
+              <a:rPr sz="1600" b="0">
+                <a:solidFill>
+                  <a:srgbClr val="333333"/>
+                </a:solidFill>
+                <a:latin typeface="Arial"/>
+              </a:rPr>
+              <a:t>A </a:t>
+            </a:r>
+            <a:r>
+              <a:rPr sz="1600" b="1">
+                <a:solidFill>
+                  <a:srgbClr val="6B8F3C"/>
+                </a:solidFill>
+                <a:latin typeface="Arial"/>
+              </a:rPr>
+              <a:t>search engine</a:t>
+            </a:r>
+            <a:r>
+              <a:rPr sz="1600" b="0">
+                <a:solidFill>
+                  <a:srgbClr val="333333"/>
+                </a:solidFill>
+                <a:latin typeface="Arial"/>
+              </a:rPr>
+              <a:t> that helps engineers and buyers find and compare 3D printing suppliers worldwide — based on technology, material, location, and price.</a:t>
+            </a:r>
+          </a:p>
+        </p:txBody>
+      </p:sp>
+      <p:sp>
+        <p:nvSpPr>
+          <p:cNvPr id="9" name="Rounded Rectangle 8"/>
+          <p:cNvSpPr/>
+          <p:nvPr/>
+        </p:nvSpPr>
+        <p:spPr>
+          <a:xfrm>
+            <a:off x="1371600" y="2926080"/>
+            <a:ext cx="2011680" cy="1645920"/>
+          </a:xfrm>
+          <a:prstGeom prst="roundRect">
+            <a:avLst/>
+          </a:prstGeom>
+          <a:solidFill>
+            <a:srgbClr val="FFFFFF"/>
+          </a:solidFill>
+          <a:ln>
+            <a:noFill/>
+          </a:ln>
+        </p:spPr>
+        <p:style>
+          <a:lnRef idx="1">
+            <a:schemeClr val="accent1"/>
+          </a:lnRef>
+          <a:fillRef idx="3">
+            <a:schemeClr val="accent1"/>
+          </a:fillRef>
+          <a:effectRef idx="2">
+            <a:schemeClr val="accent1"/>
+          </a:effectRef>
+          <a:fontRef idx="minor">
+            <a:schemeClr val="lt1"/>
+          </a:fontRef>
+        </p:style>
+        <p:txBody>
+          <a:bodyPr wrap="square" rtlCol="0" anchor="ctr"/>
+          <a:lstStyle/>
+          <a:p>
+            <a:pPr algn="ctr">
+              <a:spcBef>
+                <a:spcPts val="2000"/>
+              </a:spcBef>
+            </a:pPr>
+            <a:r>
+              <a:rPr sz="2800">
                 <a:solidFill>
                   <a:srgbClr val="1A1A1A"/>
                 </a:solidFill>
-                <a:latin typeface="Georgia"/>
-              </a:defRPr>
+              </a:rPr>
+              <a:t>👤</a:t>
+            </a:r>
+          </a:p>
+          <a:p>
+            <a:pPr algn="ctr"/>
+            <a:r>
+              <a:rPr sz="1600" b="1">
+                <a:solidFill>
+                  <a:srgbClr val="1A1A1A"/>
+                </a:solidFill>
+                <a:latin typeface="Arial"/>
+              </a:rPr>
+              <a:t>Buyer</a:t>
+            </a:r>
+          </a:p>
+          <a:p>
+            <a:pPr algn="ctr"/>
+            <a:r>
+              <a:rPr sz="1100">
+                <a:solidFill>
+                  <a:srgbClr val="555555"/>
+                </a:solidFill>
+                <a:latin typeface="Arial"/>
+              </a:rPr>
+              <a:t>Uploads specs</a:t>
+            </a:r>
+          </a:p>
+        </p:txBody>
+      </p:sp>
+      <p:sp>
+        <p:nvSpPr>
+          <p:cNvPr id="10" name="Rounded Rectangle 9"/>
+          <p:cNvSpPr/>
+          <p:nvPr/>
+        </p:nvSpPr>
+        <p:spPr>
+          <a:xfrm>
+            <a:off x="4846320" y="2926080"/>
+            <a:ext cx="2377440" cy="1645920"/>
+          </a:xfrm>
+          <a:prstGeom prst="roundRect">
+            <a:avLst/>
+          </a:prstGeom>
+          <a:solidFill>
+            <a:srgbClr val="1A1A1A"/>
+          </a:solidFill>
+          <a:ln>
+            <a:noFill/>
+          </a:ln>
+        </p:spPr>
+        <p:style>
+          <a:lnRef idx="1">
+            <a:schemeClr val="accent1"/>
+          </a:lnRef>
+          <a:fillRef idx="3">
+            <a:schemeClr val="accent1"/>
+          </a:fillRef>
+          <a:effectRef idx="2">
+            <a:schemeClr val="accent1"/>
+          </a:effectRef>
+          <a:fontRef idx="minor">
+            <a:schemeClr val="lt1"/>
+          </a:fontRef>
+        </p:style>
+        <p:txBody>
+          <a:bodyPr wrap="square" rtlCol="0" anchor="ctr"/>
+          <a:lstStyle/>
+          <a:p>
+            <a:pPr algn="ctr">
+              <a:spcBef>
+                <a:spcPts val="2000"/>
+              </a:spcBef>
             </a:pPr>
-            <a:r>
-              <a:t>Find the right 3D printing supplier</a:t>
-            </a:r>
-          </a:p>
-        </p:txBody>
-      </p:sp>
-      <p:sp>
-        <p:nvSpPr>
-          <p:cNvPr id="6" name="TextBox 5"/>
-          <p:cNvSpPr txBox="1"/>
-          <p:nvPr/>
-        </p:nvSpPr>
-        <p:spPr>
-          <a:xfrm>
-            <a:off x="1371600" y="4480560"/>
-            <a:ext cx="6400800" cy="548640"/>
-          </a:xfrm>
-          <a:prstGeom prst="rect">
-            <a:avLst/>
-          </a:prstGeom>
-          <a:noFill/>
-        </p:spPr>
-        <p:txBody>
-          <a:bodyPr wrap="none">
-            <a:spAutoFit/>
-          </a:bodyPr>
-          <a:lstStyle/>
-          <a:p>
-            <a:pPr>
-              <a:defRPr sz="1600">
+            <a:endParaRPr/>
+          </a:p>
+          <a:p>
+            <a:pPr algn="ctr"/>
+            <a:r>
+              <a:rPr sz="1600" b="1">
+                <a:solidFill>
+                  <a:srgbClr val="FFFFFF"/>
+                </a:solidFill>
+                <a:latin typeface="Arial"/>
+              </a:rPr>
+              <a:t>SupplyCheck</a:t>
+            </a:r>
+          </a:p>
+          <a:p>
+            <a:pPr algn="ctr"/>
+            <a:r>
+              <a:rPr sz="1100">
+                <a:solidFill>
+                  <a:srgbClr val="999999"/>
+                </a:solidFill>
+                <a:latin typeface="Arial"/>
+              </a:rPr>
+              <a:t>Matches &amp; compares</a:t>
+            </a:r>
+          </a:p>
+        </p:txBody>
+      </p:sp>
+      <p:sp>
+        <p:nvSpPr>
+          <p:cNvPr id="11" name="Rounded Rectangle 10"/>
+          <p:cNvSpPr/>
+          <p:nvPr/>
+        </p:nvSpPr>
+        <p:spPr>
+          <a:xfrm>
+            <a:off x="8686800" y="2926080"/>
+            <a:ext cx="2011680" cy="1645920"/>
+          </a:xfrm>
+          <a:prstGeom prst="roundRect">
+            <a:avLst/>
+          </a:prstGeom>
+          <a:solidFill>
+            <a:srgbClr val="FFFFFF"/>
+          </a:solidFill>
+          <a:ln>
+            <a:noFill/>
+          </a:ln>
+        </p:spPr>
+        <p:style>
+          <a:lnRef idx="1">
+            <a:schemeClr val="accent1"/>
+          </a:lnRef>
+          <a:fillRef idx="3">
+            <a:schemeClr val="accent1"/>
+          </a:fillRef>
+          <a:effectRef idx="2">
+            <a:schemeClr val="accent1"/>
+          </a:effectRef>
+          <a:fontRef idx="minor">
+            <a:schemeClr val="lt1"/>
+          </a:fontRef>
+        </p:style>
+        <p:txBody>
+          <a:bodyPr wrap="square" rtlCol="0" anchor="ctr"/>
+          <a:lstStyle/>
+          <a:p>
+            <a:pPr algn="ctr">
+              <a:spcBef>
+                <a:spcPts val="2000"/>
+              </a:spcBef>
+            </a:pPr>
+            <a:r>
+              <a:rPr sz="2800">
+                <a:solidFill>
+                  <a:srgbClr val="1A1A1A"/>
+                </a:solidFill>
+              </a:rPr>
+              <a:t>🏭</a:t>
+            </a:r>
+          </a:p>
+          <a:p>
+            <a:pPr algn="ctr"/>
+            <a:r>
+              <a:rPr sz="1600" b="1">
+                <a:solidFill>
+                  <a:srgbClr val="1A1A1A"/>
+                </a:solidFill>
+                <a:latin typeface="Arial"/>
+              </a:rPr>
+              <a:t>Supplier</a:t>
+            </a:r>
+          </a:p>
+          <a:p>
+            <a:pPr algn="ctr"/>
+            <a:r>
+              <a:rPr sz="1100">
                 <a:solidFill>
                   <a:srgbClr val="555555"/>
                 </a:solidFill>
                 <a:latin typeface="Arial"/>
-              </a:defRPr>
+              </a:rPr>
+              <a:t>Gets the lead</a:t>
+            </a:r>
+          </a:p>
+        </p:txBody>
+      </p:sp>
+      <p:sp>
+        <p:nvSpPr>
+          <p:cNvPr id="12" name="Right Arrow 11"/>
+          <p:cNvSpPr/>
+          <p:nvPr/>
+        </p:nvSpPr>
+        <p:spPr>
+          <a:xfrm>
+            <a:off x="3566160" y="3474720"/>
+            <a:ext cx="1097280" cy="548640"/>
+          </a:xfrm>
+          <a:prstGeom prst="rightArrow">
+            <a:avLst/>
+          </a:prstGeom>
+          <a:solidFill>
+            <a:srgbClr val="6B8F3C"/>
+          </a:solidFill>
+          <a:ln>
+            <a:noFill/>
+          </a:ln>
+        </p:spPr>
+        <p:style>
+          <a:lnRef idx="1">
+            <a:schemeClr val="accent1"/>
+          </a:lnRef>
+          <a:fillRef idx="3">
+            <a:schemeClr val="accent1"/>
+          </a:fillRef>
+          <a:effectRef idx="2">
+            <a:schemeClr val="accent1"/>
+          </a:effectRef>
+          <a:fontRef idx="minor">
+            <a:schemeClr val="lt1"/>
+          </a:fontRef>
+        </p:style>
+        <p:txBody>
+          <a:bodyPr rtlCol="0" anchor="ctr"/>
+          <a:lstStyle/>
+          <a:p>
+            <a:pPr algn="ctr"/>
+            <a:endParaRPr/>
+          </a:p>
+        </p:txBody>
+      </p:sp>
+      <p:sp>
+        <p:nvSpPr>
+          <p:cNvPr id="13" name="Right Arrow 12"/>
+          <p:cNvSpPr/>
+          <p:nvPr/>
+        </p:nvSpPr>
+        <p:spPr>
+          <a:xfrm>
+            <a:off x="7406640" y="3474720"/>
+            <a:ext cx="1097280" cy="548640"/>
+          </a:xfrm>
+          <a:prstGeom prst="rightArrow">
+            <a:avLst/>
+          </a:prstGeom>
+          <a:solidFill>
+            <a:srgbClr val="6B8F3C"/>
+          </a:solidFill>
+          <a:ln>
+            <a:noFill/>
+          </a:ln>
+        </p:spPr>
+        <p:style>
+          <a:lnRef idx="1">
+            <a:schemeClr val="accent1"/>
+          </a:lnRef>
+          <a:fillRef idx="3">
+            <a:schemeClr val="accent1"/>
+          </a:fillRef>
+          <a:effectRef idx="2">
+            <a:schemeClr val="accent1"/>
+          </a:effectRef>
+          <a:fontRef idx="minor">
+            <a:schemeClr val="lt1"/>
+          </a:fontRef>
+        </p:style>
+        <p:txBody>
+          <a:bodyPr rtlCol="0" anchor="ctr"/>
+          <a:lstStyle/>
+          <a:p>
+            <a:pPr algn="ctr"/>
+            <a:endParaRPr/>
+          </a:p>
+        </p:txBody>
+      </p:sp>
+      <p:sp>
+        <p:nvSpPr>
+          <p:cNvPr id="14" name="Rounded Rectangle 13"/>
+          <p:cNvSpPr/>
+          <p:nvPr/>
+        </p:nvSpPr>
+        <p:spPr>
+          <a:xfrm>
+            <a:off x="960120" y="5120640"/>
+            <a:ext cx="2926080" cy="1097280"/>
+          </a:xfrm>
+          <a:prstGeom prst="roundRect">
+            <a:avLst/>
+          </a:prstGeom>
+          <a:solidFill>
+            <a:srgbClr val="FFFFFF"/>
+          </a:solidFill>
+          <a:ln>
+            <a:noFill/>
+          </a:ln>
+        </p:spPr>
+        <p:style>
+          <a:lnRef idx="1">
+            <a:schemeClr val="accent1"/>
+          </a:lnRef>
+          <a:fillRef idx="3">
+            <a:schemeClr val="accent1"/>
+          </a:fillRef>
+          <a:effectRef idx="2">
+            <a:schemeClr val="accent1"/>
+          </a:effectRef>
+          <a:fontRef idx="minor">
+            <a:schemeClr val="lt1"/>
+          </a:fontRef>
+        </p:style>
+        <p:txBody>
+          <a:bodyPr rtlCol="0" anchor="ctr"/>
+          <a:lstStyle/>
+          <a:p>
+            <a:pPr algn="ctr">
+              <a:spcBef>
+                <a:spcPts val="1200"/>
+              </a:spcBef>
             </a:pPr>
             <a:r>
-              <a:t>- Simple, Transparent, Fast and For Free</a:t>
+              <a:rPr sz="2200" b="1" dirty="0">
+                <a:solidFill>
+                  <a:srgbClr val="6B8F3C"/>
+                </a:solidFill>
+                <a:latin typeface="Arial"/>
+              </a:rPr>
+              <a:t>100+</a:t>
+            </a:r>
+          </a:p>
+          <a:p>
+            <a:r>
+              <a:rPr lang="da-DK" sz="1200" dirty="0">
+                <a:solidFill>
+                  <a:srgbClr val="555555"/>
+                </a:solidFill>
+                <a:latin typeface="Arial"/>
+              </a:rPr>
+              <a:t>	</a:t>
+            </a:r>
+            <a:r>
+              <a:rPr sz="1200" dirty="0">
+                <a:solidFill>
+                  <a:srgbClr val="555555"/>
+                </a:solidFill>
+                <a:latin typeface="Arial"/>
+              </a:rPr>
+              <a:t>Suppliers listed worldwide</a:t>
+            </a:r>
+          </a:p>
+        </p:txBody>
+      </p:sp>
+      <p:sp>
+        <p:nvSpPr>
+          <p:cNvPr id="15" name="Rounded Rectangle 14"/>
+          <p:cNvSpPr/>
+          <p:nvPr/>
+        </p:nvSpPr>
+        <p:spPr>
+          <a:xfrm>
+            <a:off x="4632807" y="5120640"/>
+            <a:ext cx="2926080" cy="1097280"/>
+          </a:xfrm>
+          <a:prstGeom prst="roundRect">
+            <a:avLst/>
+          </a:prstGeom>
+          <a:solidFill>
+            <a:srgbClr val="FFFFFF"/>
+          </a:solidFill>
+          <a:ln>
+            <a:noFill/>
+          </a:ln>
+        </p:spPr>
+        <p:style>
+          <a:lnRef idx="1">
+            <a:schemeClr val="accent1"/>
+          </a:lnRef>
+          <a:fillRef idx="3">
+            <a:schemeClr val="accent1"/>
+          </a:fillRef>
+          <a:effectRef idx="2">
+            <a:schemeClr val="accent1"/>
+          </a:effectRef>
+          <a:fontRef idx="minor">
+            <a:schemeClr val="lt1"/>
+          </a:fontRef>
+        </p:style>
+        <p:txBody>
+          <a:bodyPr rtlCol="0" anchor="ctr"/>
+          <a:lstStyle/>
+          <a:p>
+            <a:pPr algn="ctr">
+              <a:spcBef>
+                <a:spcPts val="1200"/>
+              </a:spcBef>
+            </a:pPr>
+            <a:r>
+              <a:rPr sz="2200" b="1" dirty="0">
+                <a:solidFill>
+                  <a:srgbClr val="6B8F3C"/>
+                </a:solidFill>
+                <a:latin typeface="Arial"/>
+              </a:rPr>
+              <a:t>Free</a:t>
+            </a:r>
+          </a:p>
+          <a:p>
+            <a:r>
+              <a:rPr lang="da-DK" sz="1200" dirty="0">
+                <a:solidFill>
+                  <a:srgbClr val="555555"/>
+                </a:solidFill>
+                <a:latin typeface="Arial"/>
+              </a:rPr>
+              <a:t>	</a:t>
+            </a:r>
+            <a:r>
+              <a:rPr sz="1200" dirty="0">
+                <a:solidFill>
+                  <a:srgbClr val="555555"/>
+                </a:solidFill>
+                <a:latin typeface="Arial"/>
+              </a:rPr>
+              <a:t>For buyers to compare</a:t>
+            </a:r>
+          </a:p>
+        </p:txBody>
+      </p:sp>
+      <p:sp>
+        <p:nvSpPr>
+          <p:cNvPr id="16" name="Rounded Rectangle 15"/>
+          <p:cNvSpPr/>
+          <p:nvPr/>
+        </p:nvSpPr>
+        <p:spPr>
+          <a:xfrm>
+            <a:off x="8321040" y="5120640"/>
+            <a:ext cx="2926080" cy="1097280"/>
+          </a:xfrm>
+          <a:prstGeom prst="roundRect">
+            <a:avLst/>
+          </a:prstGeom>
+          <a:solidFill>
+            <a:srgbClr val="FFFFFF"/>
+          </a:solidFill>
+          <a:ln>
+            <a:noFill/>
+          </a:ln>
+        </p:spPr>
+        <p:style>
+          <a:lnRef idx="1">
+            <a:schemeClr val="accent1"/>
+          </a:lnRef>
+          <a:fillRef idx="3">
+            <a:schemeClr val="accent1"/>
+          </a:fillRef>
+          <a:effectRef idx="2">
+            <a:schemeClr val="accent1"/>
+          </a:effectRef>
+          <a:fontRef idx="minor">
+            <a:schemeClr val="lt1"/>
+          </a:fontRef>
+        </p:style>
+        <p:txBody>
+          <a:bodyPr rtlCol="0" anchor="ctr"/>
+          <a:lstStyle/>
+          <a:p>
+            <a:pPr algn="ctr">
+              <a:spcBef>
+                <a:spcPts val="1200"/>
+              </a:spcBef>
+            </a:pPr>
+            <a:r>
+              <a:rPr sz="2200" b="1" dirty="0">
+                <a:solidFill>
+                  <a:srgbClr val="6B8F3C"/>
+                </a:solidFill>
+                <a:latin typeface="Arial"/>
+              </a:rPr>
+              <a:t>Direct</a:t>
+            </a:r>
+          </a:p>
+          <a:p>
+            <a:r>
+              <a:rPr lang="da-DK" sz="1200" dirty="0">
+                <a:solidFill>
+                  <a:srgbClr val="555555"/>
+                </a:solidFill>
+                <a:latin typeface="Arial"/>
+              </a:rPr>
+              <a:t>	</a:t>
+            </a:r>
+            <a:r>
+              <a:rPr sz="1200" dirty="0">
+                <a:solidFill>
+                  <a:srgbClr val="555555"/>
+                </a:solidFill>
+                <a:latin typeface="Arial"/>
+              </a:rPr>
+              <a:t>Users go to website directly</a:t>
             </a:r>
           </a:p>
         </p:txBody>
       </p:sp>
       <p:pic>
         <p:nvPicPr>
-          <p:cNvPr id="7" name="Picture 6" descr="brand-logo-icon.png"/>
+          <p:cNvPr id="17" name="Picture 16" descr="logo-transparent.png"/>
           <p:cNvPicPr>
             <a:picLocks noChangeAspect="1"/>
           </p:cNvPicPr>
@@ -3289,50 +3935,14 @@
         </p:blipFill>
         <p:spPr>
           <a:xfrm>
-            <a:off x="9326880" y="2286000"/>
-            <a:ext cx="2194560" cy="2194560"/>
+            <a:off x="5692140" y="3017520"/>
+            <a:ext cx="685800" cy="685800"/>
           </a:xfrm>
           <a:prstGeom prst="rect">
             <a:avLst/>
           </a:prstGeom>
         </p:spPr>
       </p:pic>
-      <p:sp>
-        <p:nvSpPr>
-          <p:cNvPr id="8" name="TextBox 7"/>
-          <p:cNvSpPr txBox="1"/>
-          <p:nvPr/>
-        </p:nvSpPr>
-        <p:spPr>
-          <a:xfrm>
-            <a:off x="8869680" y="5943600"/>
-            <a:ext cx="3108960" cy="457200"/>
-          </a:xfrm>
-          <a:prstGeom prst="rect">
-            <a:avLst/>
-          </a:prstGeom>
-          <a:noFill/>
-        </p:spPr>
-        <p:txBody>
-          <a:bodyPr wrap="none">
-            <a:spAutoFit/>
-          </a:bodyPr>
-          <a:lstStyle/>
-          <a:p>
-            <a:pPr algn="ctr">
-              <a:defRPr sz="1200">
-                <a:solidFill>
-                  <a:srgbClr val="666666"/>
-                </a:solidFill>
-                <a:latin typeface="Arial"/>
-              </a:defRPr>
-            </a:pPr>
-            <a:r>
-              <a:t>Partner Presentation</a:t>
-            </a:r>
-          </a:p>
-        </p:txBody>
-      </p:sp>
     </p:spTree>
   </p:cSld>
   <p:clrMapOvr>
@@ -3342,7 +3952,7 @@
 </file>
 
 <file path=ppt/slides/slide2.xml><?xml version="1.0" encoding="utf-8"?>
-<p:sld xmlns:a="http://schemas.openxmlformats.org/drawingml/2006/main" xmlns:p="http://schemas.openxmlformats.org/presentationml/2006/main" xmlns:r="http://schemas.openxmlformats.org/officeDocument/2006/relationships">
+<p:sld xmlns:a="http://schemas.openxmlformats.org/drawingml/2006/main" xmlns:r="http://schemas.openxmlformats.org/officeDocument/2006/relationships" xmlns:p="http://schemas.openxmlformats.org/presentationml/2006/main">
   <p:cSld>
     <p:spTree>
       <p:nvGrpSpPr>
@@ -3350,7 +3960,14 @@
         <p:cNvGrpSpPr/>
         <p:nvPr/>
       </p:nvGrpSpPr>
-      <p:grpSpPr/>
+      <p:grpSpPr>
+        <a:xfrm>
+          <a:off x="0" y="0"/>
+          <a:ext cx="0" cy="0"/>
+          <a:chOff x="0" y="0"/>
+          <a:chExt cx="0" cy="0"/>
+        </a:xfrm>
+      </p:grpSpPr>
       <p:sp>
         <p:nvSpPr>
           <p:cNvPr id="2" name="Rectangle 1"/>
@@ -3360,7 +3977,7 @@
         <p:spPr>
           <a:xfrm>
             <a:off x="0" y="1280160"/>
-            <a:ext cx="12191695" cy="5577840"/>
+            <a:ext cx="12192000" cy="5577840"/>
           </a:xfrm>
           <a:prstGeom prst="rect">
             <a:avLst/>
@@ -3391,6 +4008,7 @@
           <a:lstStyle/>
           <a:p>
             <a:pPr algn="ctr"/>
+            <a:endParaRPr/>
           </a:p>
         </p:txBody>
       </p:sp>
@@ -3403,7 +4021,7 @@
         <p:spPr>
           <a:xfrm>
             <a:off x="0" y="0"/>
-            <a:ext cx="12191695" cy="1280160"/>
+            <a:ext cx="12192000" cy="1280160"/>
           </a:xfrm>
           <a:prstGeom prst="rect">
             <a:avLst/>
@@ -3434,6 +4052,7 @@
           <a:lstStyle/>
           <a:p>
             <a:pPr algn="ctr"/>
+            <a:endParaRPr/>
           </a:p>
         </p:txBody>
       </p:sp>
@@ -3468,7 +4087,7 @@
               </a:defRPr>
             </a:pPr>
             <a:r>
-              <a:t>What is SupplyCheck?</a:t>
+              <a:t>Meet the Founders</a:t>
             </a:r>
           </a:p>
         </p:txBody>
@@ -3513,6 +4132,7 @@
           <a:lstStyle/>
           <a:p>
             <a:pPr algn="ctr"/>
+            <a:endParaRPr/>
           </a:p>
         </p:txBody>
       </p:sp>
@@ -3554,7 +4174,7 @@
       </p:sp>
       <p:pic>
         <p:nvPicPr>
-          <p:cNvPr id="7" name="Picture 6" descr="amsupplycheck-logo-white.png"/>
+          <p:cNvPr id="7" name="Picture 6" descr="image.png"/>
           <p:cNvPicPr>
             <a:picLocks noChangeAspect="1"/>
           </p:cNvPicPr>
@@ -3578,66 +4198,14 @@
       </p:pic>
       <p:sp>
         <p:nvSpPr>
-          <p:cNvPr id="8" name="TextBox 7"/>
-          <p:cNvSpPr txBox="1"/>
-          <p:nvPr/>
-        </p:nvSpPr>
-        <p:spPr>
-          <a:xfrm>
-            <a:off x="731520" y="1645920"/>
-            <a:ext cx="10058400" cy="731520"/>
-          </a:xfrm>
-          <a:prstGeom prst="rect">
-            <a:avLst/>
-          </a:prstGeom>
-          <a:noFill/>
-        </p:spPr>
-        <p:txBody>
-          <a:bodyPr wrap="square">
-            <a:spAutoFit/>
-          </a:bodyPr>
-          <a:lstStyle/>
-          <a:p>
-            <a:r>
-              <a:rPr sz="1600" b="0">
-                <a:solidFill>
-                  <a:srgbClr val="333333"/>
-                </a:solidFill>
-                <a:latin typeface="Arial"/>
-              </a:rPr>
-              <a:t>A </a:t>
-            </a:r>
-            <a:r>
-              <a:rPr sz="1600" b="1">
-                <a:solidFill>
-                  <a:srgbClr val="6B8F3C"/>
-                </a:solidFill>
-                <a:latin typeface="Arial"/>
-              </a:rPr>
-              <a:t>search engine</a:t>
-            </a:r>
-            <a:r>
-              <a:rPr sz="1600" b="0">
-                <a:solidFill>
-                  <a:srgbClr val="333333"/>
-                </a:solidFill>
-                <a:latin typeface="Arial"/>
-              </a:rPr>
-              <a:t> that helps engineers and buyers find and compare 3D printing suppliers worldwide — based on technology, material, location, and price.</a:t>
-            </a:r>
-          </a:p>
-        </p:txBody>
-      </p:sp>
-      <p:sp>
-        <p:nvSpPr>
-          <p:cNvPr id="9" name="Rounded Rectangle 8"/>
+          <p:cNvPr id="8" name="Rounded Rectangle 7"/>
           <p:cNvSpPr/>
           <p:nvPr/>
         </p:nvSpPr>
         <p:spPr>
           <a:xfrm>
-            <a:off x="1371600" y="2926080"/>
-            <a:ext cx="2011680" cy="1645920"/>
+            <a:off x="746760" y="1737360"/>
+            <a:ext cx="3200400" cy="4754880"/>
           </a:xfrm>
           <a:prstGeom prst="roundRect">
             <a:avLst/>
@@ -3664,138 +4232,153 @@
           </a:fontRef>
         </p:style>
         <p:txBody>
-          <a:bodyPr rtlCol="0" anchor="ctr" wrap="square"/>
-          <a:lstStyle/>
-          <a:p>
-            <a:pPr algn="ctr">
-              <a:spcBef>
-                <a:spcPts val="2000"/>
-              </a:spcBef>
-            </a:pPr>
-            <a:r>
-              <a:rPr sz="2800">
+          <a:bodyPr rtlCol="0" anchor="ctr"/>
+          <a:lstStyle/>
+          <a:p>
+            <a:pPr algn="ctr"/>
+            <a:endParaRPr/>
+          </a:p>
+        </p:txBody>
+      </p:sp>
+      <p:sp>
+        <p:nvSpPr>
+          <p:cNvPr id="10" name="TextBox 9"/>
+          <p:cNvSpPr txBox="1"/>
+          <p:nvPr/>
+        </p:nvSpPr>
+        <p:spPr>
+          <a:xfrm>
+            <a:off x="883920" y="3200400"/>
+            <a:ext cx="2926080" cy="548640"/>
+          </a:xfrm>
+          <a:prstGeom prst="rect">
+            <a:avLst/>
+          </a:prstGeom>
+          <a:noFill/>
+        </p:spPr>
+        <p:txBody>
+          <a:bodyPr wrap="square">
+            <a:spAutoFit/>
+          </a:bodyPr>
+          <a:lstStyle/>
+          <a:p>
+            <a:pPr algn="ctr"/>
+            <a:r>
+              <a:rPr sz="1400">
+                <a:solidFill>
+                  <a:srgbClr val="AAAAAA"/>
+                </a:solidFill>
+                <a:latin typeface="Arial"/>
+              </a:rPr>
+              <a:t>Insert image</a:t>
+            </a:r>
+          </a:p>
+        </p:txBody>
+      </p:sp>
+      <p:sp>
+        <p:nvSpPr>
+          <p:cNvPr id="11" name="TextBox 10"/>
+          <p:cNvSpPr txBox="1"/>
+          <p:nvPr/>
+        </p:nvSpPr>
+        <p:spPr>
+          <a:xfrm>
+            <a:off x="746760" y="5440680"/>
+            <a:ext cx="3200400" cy="369332"/>
+          </a:xfrm>
+          <a:prstGeom prst="rect">
+            <a:avLst/>
+          </a:prstGeom>
+          <a:noFill/>
+        </p:spPr>
+        <p:txBody>
+          <a:bodyPr wrap="square">
+            <a:spAutoFit/>
+          </a:bodyPr>
+          <a:lstStyle/>
+          <a:p>
+            <a:pPr algn="ctr"/>
+            <a:r>
+              <a:rPr lang="da-DK" sz="1800" b="1" dirty="0">
                 <a:solidFill>
                   <a:srgbClr val="1A1A1A"/>
                 </a:solidFill>
-              </a:rPr>
-              <a:t>👤</a:t>
-            </a:r>
-          </a:p>
+                <a:latin typeface="Georgia"/>
+              </a:rPr>
+              <a:t>Rasmus Henriksen</a:t>
+            </a:r>
+            <a:endParaRPr sz="1800" b="1" dirty="0">
+              <a:solidFill>
+                <a:srgbClr val="1A1A1A"/>
+              </a:solidFill>
+              <a:latin typeface="Georgia"/>
+            </a:endParaRPr>
+          </a:p>
+        </p:txBody>
+      </p:sp>
+      <p:sp>
+        <p:nvSpPr>
+          <p:cNvPr id="12" name="TextBox 11"/>
+          <p:cNvSpPr txBox="1"/>
+          <p:nvPr/>
+        </p:nvSpPr>
+        <p:spPr>
+          <a:xfrm>
+            <a:off x="746760" y="5806440"/>
+            <a:ext cx="3200400" cy="307777"/>
+          </a:xfrm>
+          <a:prstGeom prst="rect">
+            <a:avLst/>
+          </a:prstGeom>
+          <a:noFill/>
+        </p:spPr>
+        <p:txBody>
+          <a:bodyPr wrap="square">
+            <a:spAutoFit/>
+          </a:bodyPr>
+          <a:lstStyle/>
           <a:p>
             <a:pPr algn="ctr"/>
             <a:r>
-              <a:rPr sz="1600" b="1">
-                <a:solidFill>
-                  <a:srgbClr val="1A1A1A"/>
+              <a:rPr sz="1400" b="1" dirty="0">
+                <a:solidFill>
+                  <a:srgbClr val="6B8F3C"/>
                 </a:solidFill>
                 <a:latin typeface="Arial"/>
               </a:rPr>
-              <a:t>Buyer</a:t>
-            </a:r>
-          </a:p>
-          <a:p>
-            <a:pPr algn="ctr"/>
-            <a:r>
-              <a:rPr sz="1100">
-                <a:solidFill>
-                  <a:srgbClr val="555555"/>
+              <a:t>Co-Founder &amp; C</a:t>
+            </a:r>
+            <a:r>
+              <a:rPr lang="da-DK" sz="1400" b="1" dirty="0">
+                <a:solidFill>
+                  <a:srgbClr val="6B8F3C"/>
                 </a:solidFill>
                 <a:latin typeface="Arial"/>
               </a:rPr>
-              <a:t>Uploads specs</a:t>
-            </a:r>
-          </a:p>
-        </p:txBody>
-      </p:sp>
-      <p:sp>
-        <p:nvSpPr>
-          <p:cNvPr id="10" name="Rounded Rectangle 9"/>
+              <a:t>M</a:t>
+            </a:r>
+            <a:r>
+              <a:rPr sz="1400" b="1" dirty="0">
+                <a:solidFill>
+                  <a:srgbClr val="6B8F3C"/>
+                </a:solidFill>
+                <a:latin typeface="Arial"/>
+              </a:rPr>
+              <a:t>O</a:t>
+            </a:r>
+          </a:p>
+        </p:txBody>
+      </p:sp>
+      <p:sp>
+        <p:nvSpPr>
+          <p:cNvPr id="13" name="Rounded Rectangle 12"/>
           <p:cNvSpPr/>
           <p:nvPr/>
         </p:nvSpPr>
         <p:spPr>
           <a:xfrm>
-            <a:off x="4846320" y="2926080"/>
-            <a:ext cx="2377440" cy="1645920"/>
-          </a:xfrm>
-          <a:prstGeom prst="roundRect">
-            <a:avLst/>
-          </a:prstGeom>
-          <a:solidFill>
-            <a:srgbClr val="1A1A1A"/>
-          </a:solidFill>
-          <a:ln>
-            <a:noFill/>
-          </a:ln>
-        </p:spPr>
-        <p:style>
-          <a:lnRef idx="1">
-            <a:schemeClr val="accent1"/>
-          </a:lnRef>
-          <a:fillRef idx="3">
-            <a:schemeClr val="accent1"/>
-          </a:fillRef>
-          <a:effectRef idx="2">
-            <a:schemeClr val="accent1"/>
-          </a:effectRef>
-          <a:fontRef idx="minor">
-            <a:schemeClr val="lt1"/>
-          </a:fontRef>
-        </p:style>
-        <p:txBody>
-          <a:bodyPr rtlCol="0" anchor="ctr" wrap="square"/>
-          <a:lstStyle/>
-          <a:p>
-            <a:pPr algn="ctr">
-              <a:spcBef>
-                <a:spcPts val="2000"/>
-              </a:spcBef>
-            </a:pPr>
-            <a:r>
-              <a:rPr sz="2800">
-                <a:solidFill>
-                  <a:srgbClr val="6B8F3C"/>
-                </a:solidFill>
-              </a:rPr>
-              <a:t>✔</a:t>
-            </a:r>
-          </a:p>
-          <a:p>
-            <a:pPr algn="ctr"/>
-            <a:r>
-              <a:rPr sz="1600" b="1">
-                <a:solidFill>
-                  <a:srgbClr val="FFFFFF"/>
-                </a:solidFill>
-                <a:latin typeface="Arial"/>
-              </a:rPr>
-              <a:t>SupplyCheck</a:t>
-            </a:r>
-          </a:p>
-          <a:p>
-            <a:pPr algn="ctr"/>
-            <a:r>
-              <a:rPr sz="1100">
-                <a:solidFill>
-                  <a:srgbClr val="999999"/>
-                </a:solidFill>
-                <a:latin typeface="Arial"/>
-              </a:rPr>
-              <a:t>Matches &amp; compares</a:t>
-            </a:r>
-          </a:p>
-        </p:txBody>
-      </p:sp>
-      <p:sp>
-        <p:nvSpPr>
-          <p:cNvPr id="11" name="Rounded Rectangle 10"/>
-          <p:cNvSpPr/>
-          <p:nvPr/>
-        </p:nvSpPr>
-        <p:spPr>
-          <a:xfrm>
-            <a:off x="8686800" y="2926080"/>
-            <a:ext cx="2011680" cy="1645920"/>
+            <a:off x="4495800" y="1737360"/>
+            <a:ext cx="3200400" cy="4754880"/>
           </a:xfrm>
           <a:prstGeom prst="roundRect">
             <a:avLst/>
@@ -3822,145 +4405,135 @@
           </a:fontRef>
         </p:style>
         <p:txBody>
-          <a:bodyPr rtlCol="0" anchor="ctr" wrap="square"/>
-          <a:lstStyle/>
-          <a:p>
-            <a:pPr algn="ctr">
-              <a:spcBef>
-                <a:spcPts val="2000"/>
-              </a:spcBef>
-            </a:pPr>
-            <a:r>
-              <a:rPr sz="2800">
+          <a:bodyPr rtlCol="0" anchor="ctr"/>
+          <a:lstStyle/>
+          <a:p>
+            <a:pPr algn="ctr"/>
+            <a:endParaRPr/>
+          </a:p>
+        </p:txBody>
+      </p:sp>
+      <p:sp>
+        <p:nvSpPr>
+          <p:cNvPr id="15" name="TextBox 14"/>
+          <p:cNvSpPr txBox="1"/>
+          <p:nvPr/>
+        </p:nvSpPr>
+        <p:spPr>
+          <a:xfrm>
+            <a:off x="4632960" y="3200400"/>
+            <a:ext cx="2926080" cy="548640"/>
+          </a:xfrm>
+          <a:prstGeom prst="rect">
+            <a:avLst/>
+          </a:prstGeom>
+          <a:noFill/>
+        </p:spPr>
+        <p:txBody>
+          <a:bodyPr wrap="square">
+            <a:spAutoFit/>
+          </a:bodyPr>
+          <a:lstStyle/>
+          <a:p>
+            <a:pPr algn="ctr"/>
+            <a:r>
+              <a:rPr sz="1400">
+                <a:solidFill>
+                  <a:srgbClr val="AAAAAA"/>
+                </a:solidFill>
+                <a:latin typeface="Arial"/>
+              </a:rPr>
+              <a:t>Insert image</a:t>
+            </a:r>
+          </a:p>
+        </p:txBody>
+      </p:sp>
+      <p:sp>
+        <p:nvSpPr>
+          <p:cNvPr id="16" name="TextBox 15"/>
+          <p:cNvSpPr txBox="1"/>
+          <p:nvPr/>
+        </p:nvSpPr>
+        <p:spPr>
+          <a:xfrm>
+            <a:off x="4495800" y="5440680"/>
+            <a:ext cx="3200400" cy="369332"/>
+          </a:xfrm>
+          <a:prstGeom prst="rect">
+            <a:avLst/>
+          </a:prstGeom>
+          <a:noFill/>
+        </p:spPr>
+        <p:txBody>
+          <a:bodyPr wrap="square">
+            <a:spAutoFit/>
+          </a:bodyPr>
+          <a:lstStyle/>
+          <a:p>
+            <a:pPr algn="ctr"/>
+            <a:r>
+              <a:rPr lang="da-DK" sz="1800" b="1" dirty="0">
                 <a:solidFill>
                   <a:srgbClr val="1A1A1A"/>
                 </a:solidFill>
-              </a:rPr>
-              <a:t>🏭</a:t>
-            </a:r>
-          </a:p>
+                <a:latin typeface="Georgia"/>
+              </a:rPr>
+              <a:t>Kristoffer Ryelund</a:t>
+            </a:r>
+            <a:endParaRPr sz="1800" b="1" dirty="0">
+              <a:solidFill>
+                <a:srgbClr val="1A1A1A"/>
+              </a:solidFill>
+              <a:latin typeface="Georgia"/>
+            </a:endParaRPr>
+          </a:p>
+        </p:txBody>
+      </p:sp>
+      <p:sp>
+        <p:nvSpPr>
+          <p:cNvPr id="17" name="TextBox 16"/>
+          <p:cNvSpPr txBox="1"/>
+          <p:nvPr/>
+        </p:nvSpPr>
+        <p:spPr>
+          <a:xfrm>
+            <a:off x="4495800" y="5806440"/>
+            <a:ext cx="3200400" cy="307777"/>
+          </a:xfrm>
+          <a:prstGeom prst="rect">
+            <a:avLst/>
+          </a:prstGeom>
+          <a:noFill/>
+        </p:spPr>
+        <p:txBody>
+          <a:bodyPr wrap="square">
+            <a:spAutoFit/>
+          </a:bodyPr>
+          <a:lstStyle/>
           <a:p>
             <a:pPr algn="ctr"/>
             <a:r>
-              <a:rPr sz="1600" b="1">
-                <a:solidFill>
-                  <a:srgbClr val="1A1A1A"/>
+              <a:rPr sz="1400" b="1" dirty="0">
+                <a:solidFill>
+                  <a:srgbClr val="6B8F3C"/>
                 </a:solidFill>
                 <a:latin typeface="Arial"/>
               </a:rPr>
-              <a:t>Supplier</a:t>
-            </a:r>
-          </a:p>
-          <a:p>
-            <a:pPr algn="ctr"/>
-            <a:r>
-              <a:rPr sz="1100">
-                <a:solidFill>
-                  <a:srgbClr val="555555"/>
-                </a:solidFill>
-                <a:latin typeface="Arial"/>
-              </a:rPr>
-              <a:t>Gets the lead</a:t>
-            </a:r>
-          </a:p>
-        </p:txBody>
-      </p:sp>
-      <p:sp>
-        <p:nvSpPr>
-          <p:cNvPr id="12" name="Right Arrow 11"/>
+              <a:t>Co-Founder</a:t>
+            </a:r>
+          </a:p>
+        </p:txBody>
+      </p:sp>
+      <p:sp>
+        <p:nvSpPr>
+          <p:cNvPr id="18" name="Rounded Rectangle 17"/>
           <p:cNvSpPr/>
           <p:nvPr/>
         </p:nvSpPr>
         <p:spPr>
           <a:xfrm>
-            <a:off x="3566160" y="3474720"/>
-            <a:ext cx="1097280" cy="548640"/>
-          </a:xfrm>
-          <a:prstGeom prst="rightArrow">
-            <a:avLst/>
-          </a:prstGeom>
-          <a:solidFill>
-            <a:srgbClr val="6B8F3C"/>
-          </a:solidFill>
-          <a:ln>
-            <a:noFill/>
-          </a:ln>
-        </p:spPr>
-        <p:style>
-          <a:lnRef idx="1">
-            <a:schemeClr val="accent1"/>
-          </a:lnRef>
-          <a:fillRef idx="3">
-            <a:schemeClr val="accent1"/>
-          </a:fillRef>
-          <a:effectRef idx="2">
-            <a:schemeClr val="accent1"/>
-          </a:effectRef>
-          <a:fontRef idx="minor">
-            <a:schemeClr val="lt1"/>
-          </a:fontRef>
-        </p:style>
-        <p:txBody>
-          <a:bodyPr rtlCol="0" anchor="ctr"/>
-          <a:lstStyle/>
-          <a:p>
-            <a:pPr algn="ctr"/>
-          </a:p>
-        </p:txBody>
-      </p:sp>
-      <p:sp>
-        <p:nvSpPr>
-          <p:cNvPr id="13" name="Right Arrow 12"/>
-          <p:cNvSpPr/>
-          <p:nvPr/>
-        </p:nvSpPr>
-        <p:spPr>
-          <a:xfrm>
-            <a:off x="7406640" y="3474720"/>
-            <a:ext cx="1097280" cy="548640"/>
-          </a:xfrm>
-          <a:prstGeom prst="rightArrow">
-            <a:avLst/>
-          </a:prstGeom>
-          <a:solidFill>
-            <a:srgbClr val="6B8F3C"/>
-          </a:solidFill>
-          <a:ln>
-            <a:noFill/>
-          </a:ln>
-        </p:spPr>
-        <p:style>
-          <a:lnRef idx="1">
-            <a:schemeClr val="accent1"/>
-          </a:lnRef>
-          <a:fillRef idx="3">
-            <a:schemeClr val="accent1"/>
-          </a:fillRef>
-          <a:effectRef idx="2">
-            <a:schemeClr val="accent1"/>
-          </a:effectRef>
-          <a:fontRef idx="minor">
-            <a:schemeClr val="lt1"/>
-          </a:fontRef>
-        </p:style>
-        <p:txBody>
-          <a:bodyPr rtlCol="0" anchor="ctr"/>
-          <a:lstStyle/>
-          <a:p>
-            <a:pPr algn="ctr"/>
-          </a:p>
-        </p:txBody>
-      </p:sp>
-      <p:sp>
-        <p:nvSpPr>
-          <p:cNvPr id="14" name="Rounded Rectangle 13"/>
-          <p:cNvSpPr/>
-          <p:nvPr/>
-        </p:nvSpPr>
-        <p:spPr>
-          <a:xfrm>
-            <a:off x="1371600" y="5120640"/>
-            <a:ext cx="2926080" cy="1097280"/>
+            <a:off x="8244840" y="1737360"/>
+            <a:ext cx="3200400" cy="4754880"/>
           </a:xfrm>
           <a:prstGeom prst="roundRect">
             <a:avLst/>
@@ -3990,168 +4563,227 @@
           <a:bodyPr rtlCol="0" anchor="ctr"/>
           <a:lstStyle/>
           <a:p>
-            <a:pPr algn="ctr">
-              <a:spcBef>
-                <a:spcPts val="1200"/>
-              </a:spcBef>
-            </a:pPr>
-            <a:r>
-              <a:rPr sz="2200" b="1">
+            <a:pPr algn="ctr"/>
+            <a:endParaRPr/>
+          </a:p>
+        </p:txBody>
+      </p:sp>
+      <p:sp>
+        <p:nvSpPr>
+          <p:cNvPr id="20" name="TextBox 19"/>
+          <p:cNvSpPr txBox="1"/>
+          <p:nvPr/>
+        </p:nvSpPr>
+        <p:spPr>
+          <a:xfrm>
+            <a:off x="8382000" y="3200400"/>
+            <a:ext cx="2926080" cy="548640"/>
+          </a:xfrm>
+          <a:prstGeom prst="rect">
+            <a:avLst/>
+          </a:prstGeom>
+          <a:noFill/>
+        </p:spPr>
+        <p:txBody>
+          <a:bodyPr wrap="square">
+            <a:spAutoFit/>
+          </a:bodyPr>
+          <a:lstStyle/>
+          <a:p>
+            <a:pPr algn="ctr"/>
+            <a:r>
+              <a:rPr sz="1400">
+                <a:solidFill>
+                  <a:srgbClr val="AAAAAA"/>
+                </a:solidFill>
+                <a:latin typeface="Arial"/>
+              </a:rPr>
+              <a:t>Insert image</a:t>
+            </a:r>
+          </a:p>
+        </p:txBody>
+      </p:sp>
+      <p:sp>
+        <p:nvSpPr>
+          <p:cNvPr id="21" name="TextBox 20"/>
+          <p:cNvSpPr txBox="1"/>
+          <p:nvPr/>
+        </p:nvSpPr>
+        <p:spPr>
+          <a:xfrm>
+            <a:off x="8244840" y="5440680"/>
+            <a:ext cx="3200400" cy="369332"/>
+          </a:xfrm>
+          <a:prstGeom prst="rect">
+            <a:avLst/>
+          </a:prstGeom>
+          <a:noFill/>
+        </p:spPr>
+        <p:txBody>
+          <a:bodyPr wrap="square">
+            <a:spAutoFit/>
+          </a:bodyPr>
+          <a:lstStyle/>
+          <a:p>
+            <a:pPr algn="ctr"/>
+            <a:r>
+              <a:rPr lang="da-DK" sz="1800" b="1" dirty="0">
+                <a:solidFill>
+                  <a:srgbClr val="1A1A1A"/>
+                </a:solidFill>
+                <a:latin typeface="Georgia"/>
+              </a:rPr>
+              <a:t>Christian Groth</a:t>
+            </a:r>
+            <a:endParaRPr sz="1800" b="1" dirty="0">
+              <a:solidFill>
+                <a:srgbClr val="1A1A1A"/>
+              </a:solidFill>
+              <a:latin typeface="Georgia"/>
+            </a:endParaRPr>
+          </a:p>
+        </p:txBody>
+      </p:sp>
+      <p:sp>
+        <p:nvSpPr>
+          <p:cNvPr id="22" name="TextBox 21"/>
+          <p:cNvSpPr txBox="1"/>
+          <p:nvPr/>
+        </p:nvSpPr>
+        <p:spPr>
+          <a:xfrm>
+            <a:off x="8244840" y="5806440"/>
+            <a:ext cx="3200400" cy="307777"/>
+          </a:xfrm>
+          <a:prstGeom prst="rect">
+            <a:avLst/>
+          </a:prstGeom>
+          <a:noFill/>
+        </p:spPr>
+        <p:txBody>
+          <a:bodyPr wrap="square">
+            <a:spAutoFit/>
+          </a:bodyPr>
+          <a:lstStyle/>
+          <a:p>
+            <a:pPr algn="ctr"/>
+            <a:r>
+              <a:rPr sz="1400" b="1" dirty="0">
                 <a:solidFill>
                   <a:srgbClr val="6B8F3C"/>
                 </a:solidFill>
                 <a:latin typeface="Arial"/>
               </a:rPr>
-              <a:t>100+</a:t>
-            </a:r>
-          </a:p>
-          <a:p>
-            <a:r>
-              <a:rPr sz="1200">
-                <a:solidFill>
-                  <a:srgbClr val="555555"/>
+              <a:t>Co-Founder &amp; C</a:t>
+            </a:r>
+            <a:r>
+              <a:rPr lang="da-DK" sz="1400" b="1" dirty="0">
+                <a:solidFill>
+                  <a:srgbClr val="6B8F3C"/>
                 </a:solidFill>
                 <a:latin typeface="Arial"/>
               </a:rPr>
-              <a:t>Suppliers listed worldwide</a:t>
-            </a:r>
-          </a:p>
-        </p:txBody>
-      </p:sp>
-      <p:sp>
-        <p:nvSpPr>
-          <p:cNvPr id="15" name="Rounded Rectangle 14"/>
-          <p:cNvSpPr/>
-          <p:nvPr/>
-        </p:nvSpPr>
-        <p:spPr>
-          <a:xfrm>
-            <a:off x="4846320" y="5120640"/>
-            <a:ext cx="2926080" cy="1097280"/>
-          </a:xfrm>
-          <a:prstGeom prst="roundRect">
-            <a:avLst/>
-          </a:prstGeom>
-          <a:solidFill>
-            <a:srgbClr val="FFFFFF"/>
-          </a:solidFill>
-          <a:ln>
-            <a:noFill/>
-          </a:ln>
-        </p:spPr>
-        <p:style>
-          <a:lnRef idx="1">
-            <a:schemeClr val="accent1"/>
-          </a:lnRef>
-          <a:fillRef idx="3">
-            <a:schemeClr val="accent1"/>
-          </a:fillRef>
-          <a:effectRef idx="2">
-            <a:schemeClr val="accent1"/>
-          </a:effectRef>
-          <a:fontRef idx="minor">
-            <a:schemeClr val="lt1"/>
-          </a:fontRef>
-        </p:style>
-        <p:txBody>
-          <a:bodyPr rtlCol="0" anchor="ctr"/>
-          <a:lstStyle/>
-          <a:p>
-            <a:pPr algn="ctr">
-              <a:spcBef>
-                <a:spcPts val="1200"/>
-              </a:spcBef>
-            </a:pPr>
-            <a:r>
-              <a:rPr sz="2200" b="1">
-                <a:solidFill>
-                  <a:srgbClr val="6B8F3C"/>
-                </a:solidFill>
-                <a:latin typeface="Arial"/>
-              </a:rPr>
-              <a:t>Free</a:t>
-            </a:r>
-          </a:p>
-          <a:p>
-            <a:r>
-              <a:rPr sz="1200">
-                <a:solidFill>
-                  <a:srgbClr val="555555"/>
-                </a:solidFill>
-                <a:latin typeface="Arial"/>
-              </a:rPr>
-              <a:t>For buyers to search &amp; compare</a:t>
-            </a:r>
-          </a:p>
-        </p:txBody>
-      </p:sp>
-      <p:sp>
-        <p:nvSpPr>
-          <p:cNvPr id="16" name="Rounded Rectangle 15"/>
-          <p:cNvSpPr/>
-          <p:nvPr/>
-        </p:nvSpPr>
-        <p:spPr>
-          <a:xfrm>
-            <a:off x="8321040" y="5120640"/>
-            <a:ext cx="2926080" cy="1097280"/>
-          </a:xfrm>
-          <a:prstGeom prst="roundRect">
-            <a:avLst/>
-          </a:prstGeom>
-          <a:solidFill>
-            <a:srgbClr val="FFFFFF"/>
-          </a:solidFill>
-          <a:ln>
-            <a:noFill/>
-          </a:ln>
-        </p:spPr>
-        <p:style>
-          <a:lnRef idx="1">
-            <a:schemeClr val="accent1"/>
-          </a:lnRef>
-          <a:fillRef idx="3">
-            <a:schemeClr val="accent1"/>
-          </a:fillRef>
-          <a:effectRef idx="2">
-            <a:schemeClr val="accent1"/>
-          </a:effectRef>
-          <a:fontRef idx="minor">
-            <a:schemeClr val="lt1"/>
-          </a:fontRef>
-        </p:style>
-        <p:txBody>
-          <a:bodyPr rtlCol="0" anchor="ctr"/>
-          <a:lstStyle/>
-          <a:p>
-            <a:pPr algn="ctr">
-              <a:spcBef>
-                <a:spcPts val="1200"/>
-              </a:spcBef>
-            </a:pPr>
-            <a:r>
-              <a:rPr sz="2200" b="1">
-                <a:solidFill>
-                  <a:srgbClr val="6B8F3C"/>
-                </a:solidFill>
-                <a:latin typeface="Arial"/>
-              </a:rPr>
-              <a:t>Direct</a:t>
-            </a:r>
-          </a:p>
-          <a:p>
-            <a:r>
-              <a:rPr sz="1200">
-                <a:solidFill>
-                  <a:srgbClr val="555555"/>
-                </a:solidFill>
-                <a:latin typeface="Arial"/>
-              </a:rPr>
-              <a:t>Users go to your website directly</a:t>
-            </a:r>
-          </a:p>
-        </p:txBody>
-      </p:sp>
+              <a:t>EO/CMO</a:t>
+            </a:r>
+            <a:endParaRPr sz="1400" b="1" dirty="0">
+              <a:solidFill>
+                <a:srgbClr val="6B8F3C"/>
+              </a:solidFill>
+              <a:latin typeface="Arial"/>
+            </a:endParaRPr>
+          </a:p>
+        </p:txBody>
+      </p:sp>
+      <p:pic>
+        <p:nvPicPr>
+          <p:cNvPr id="24" name="Billede 23">
+            <a:extLst>
+              <a:ext uri="{FF2B5EF4-FFF2-40B4-BE49-F238E27FC236}">
+                <a16:creationId xmlns:a16="http://schemas.microsoft.com/office/drawing/2014/main" id="{3E3105C7-5951-973B-D878-8AB2F2AB5C5A}"/>
+              </a:ext>
+            </a:extLst>
+          </p:cNvPr>
+          <p:cNvPicPr>
+            <a:picLocks noChangeAspect="1"/>
+          </p:cNvPicPr>
+          <p:nvPr/>
+        </p:nvPicPr>
+        <p:blipFill>
+          <a:blip r:embed="rId3"/>
+          <a:stretch>
+            <a:fillRect/>
+          </a:stretch>
+        </p:blipFill>
+        <p:spPr>
+          <a:xfrm>
+            <a:off x="746760" y="2046515"/>
+            <a:ext cx="3211286" cy="3211286"/>
+          </a:xfrm>
+          <a:prstGeom prst="rect">
+            <a:avLst/>
+          </a:prstGeom>
+        </p:spPr>
+      </p:pic>
+      <p:pic>
+        <p:nvPicPr>
+          <p:cNvPr id="26" name="Billede 25">
+            <a:extLst>
+              <a:ext uri="{FF2B5EF4-FFF2-40B4-BE49-F238E27FC236}">
+                <a16:creationId xmlns:a16="http://schemas.microsoft.com/office/drawing/2014/main" id="{D876A82A-2821-F00D-8A14-EF8616EA5F3F}"/>
+              </a:ext>
+            </a:extLst>
+          </p:cNvPr>
+          <p:cNvPicPr>
+            <a:picLocks noChangeAspect="1"/>
+          </p:cNvPicPr>
+          <p:nvPr/>
+        </p:nvPicPr>
+        <p:blipFill>
+          <a:blip r:embed="rId4"/>
+          <a:stretch>
+            <a:fillRect/>
+          </a:stretch>
+        </p:blipFill>
+        <p:spPr>
+          <a:xfrm>
+            <a:off x="4484914" y="2055224"/>
+            <a:ext cx="3211286" cy="3211286"/>
+          </a:xfrm>
+          <a:prstGeom prst="rect">
+            <a:avLst/>
+          </a:prstGeom>
+        </p:spPr>
+      </p:pic>
+      <p:pic>
+        <p:nvPicPr>
+          <p:cNvPr id="28" name="Billede 27">
+            <a:extLst>
+              <a:ext uri="{FF2B5EF4-FFF2-40B4-BE49-F238E27FC236}">
+                <a16:creationId xmlns:a16="http://schemas.microsoft.com/office/drawing/2014/main" id="{3BA05CFD-5A2A-60B7-A53C-983889BD6E13}"/>
+              </a:ext>
+            </a:extLst>
+          </p:cNvPr>
+          <p:cNvPicPr>
+            <a:picLocks noChangeAspect="1"/>
+          </p:cNvPicPr>
+          <p:nvPr/>
+        </p:nvPicPr>
+        <p:blipFill>
+          <a:blip r:embed="rId5"/>
+          <a:stretch>
+            <a:fillRect/>
+          </a:stretch>
+        </p:blipFill>
+        <p:spPr>
+          <a:xfrm>
+            <a:off x="8223068" y="2046514"/>
+            <a:ext cx="3211286" cy="3211286"/>
+          </a:xfrm>
+          <a:prstGeom prst="rect">
+            <a:avLst/>
+          </a:prstGeom>
+        </p:spPr>
+      </p:pic>
     </p:spTree>
   </p:cSld>
   <p:clrMapOvr>
@@ -4161,7 +4793,7 @@
 </file>
 
 <file path=ppt/slides/slide3.xml><?xml version="1.0" encoding="utf-8"?>
-<p:sld xmlns:a="http://schemas.openxmlformats.org/drawingml/2006/main" xmlns:p="http://schemas.openxmlformats.org/presentationml/2006/main" xmlns:r="http://schemas.openxmlformats.org/officeDocument/2006/relationships">
+<p:sld xmlns:a="http://schemas.openxmlformats.org/drawingml/2006/main" xmlns:r="http://schemas.openxmlformats.org/officeDocument/2006/relationships" xmlns:p="http://schemas.openxmlformats.org/presentationml/2006/main">
   <p:cSld>
     <p:spTree>
       <p:nvGrpSpPr>
@@ -4169,7 +4801,14 @@
         <p:cNvGrpSpPr/>
         <p:nvPr/>
       </p:nvGrpSpPr>
-      <p:grpSpPr/>
+      <p:grpSpPr>
+        <a:xfrm>
+          <a:off x="0" y="0"/>
+          <a:ext cx="0" cy="0"/>
+          <a:chOff x="0" y="0"/>
+          <a:chExt cx="0" cy="0"/>
+        </a:xfrm>
+      </p:grpSpPr>
       <p:sp>
         <p:nvSpPr>
           <p:cNvPr id="2" name="Rectangle 1"/>
@@ -4185,7 +4824,7 @@
             <a:avLst/>
           </a:prstGeom>
           <a:solidFill>
-            <a:srgbClr val="F2F2F2"/>
+            <a:srgbClr val="FFFFFF"/>
           </a:solidFill>
           <a:ln>
             <a:noFill/>
@@ -4210,6 +4849,7 @@
           <a:lstStyle/>
           <a:p>
             <a:pPr algn="ctr"/>
+            <a:endParaRPr/>
           </a:p>
         </p:txBody>
       </p:sp>
@@ -4253,6 +4893,7 @@
           <a:lstStyle/>
           <a:p>
             <a:pPr algn="ctr"/>
+            <a:endParaRPr/>
           </a:p>
         </p:txBody>
       </p:sp>
@@ -4332,6 +4973,7 @@
           <a:lstStyle/>
           <a:p>
             <a:pPr algn="ctr"/>
+            <a:endParaRPr/>
           </a:p>
         </p:txBody>
       </p:sp>
@@ -4449,57 +5091,6 @@
       </p:sp>
       <p:sp>
         <p:nvSpPr>
-          <p:cNvPr id="9" name="Rounded Rectangle 8"/>
-          <p:cNvSpPr/>
-          <p:nvPr/>
-        </p:nvSpPr>
-        <p:spPr>
-          <a:xfrm>
-            <a:off x="731520" y="2560320"/>
-            <a:ext cx="457200" cy="457200"/>
-          </a:xfrm>
-          <a:prstGeom prst="roundRect">
-            <a:avLst/>
-          </a:prstGeom>
-          <a:solidFill>
-            <a:srgbClr val="6B8F3C"/>
-          </a:solidFill>
-          <a:ln>
-            <a:noFill/>
-          </a:ln>
-        </p:spPr>
-        <p:style>
-          <a:lnRef idx="1">
-            <a:schemeClr val="accent1"/>
-          </a:lnRef>
-          <a:fillRef idx="3">
-            <a:schemeClr val="accent1"/>
-          </a:fillRef>
-          <a:effectRef idx="2">
-            <a:schemeClr val="accent1"/>
-          </a:effectRef>
-          <a:fontRef idx="minor">
-            <a:schemeClr val="lt1"/>
-          </a:fontRef>
-        </p:style>
-        <p:txBody>
-          <a:bodyPr rtlCol="0" anchor="ctr"/>
-          <a:lstStyle/>
-          <a:p>
-            <a:pPr algn="ctr"/>
-            <a:r>
-              <a:rPr sz="1400">
-                <a:solidFill>
-                  <a:srgbClr val="FFFFFF"/>
-                </a:solidFill>
-              </a:rPr>
-              <a:t>✔</a:t>
-            </a:r>
-          </a:p>
-        </p:txBody>
-      </p:sp>
-      <p:sp>
-        <p:nvSpPr>
           <p:cNvPr id="10" name="TextBox 9"/>
           <p:cNvSpPr txBox="1"/>
           <p:nvPr/>
@@ -4568,57 +5159,6 @@
       </p:sp>
       <p:sp>
         <p:nvSpPr>
-          <p:cNvPr id="12" name="Rounded Rectangle 11"/>
-          <p:cNvSpPr/>
-          <p:nvPr/>
-        </p:nvSpPr>
-        <p:spPr>
-          <a:xfrm>
-            <a:off x="731520" y="3566160"/>
-            <a:ext cx="457200" cy="457200"/>
-          </a:xfrm>
-          <a:prstGeom prst="roundRect">
-            <a:avLst/>
-          </a:prstGeom>
-          <a:solidFill>
-            <a:srgbClr val="6B8F3C"/>
-          </a:solidFill>
-          <a:ln>
-            <a:noFill/>
-          </a:ln>
-        </p:spPr>
-        <p:style>
-          <a:lnRef idx="1">
-            <a:schemeClr val="accent1"/>
-          </a:lnRef>
-          <a:fillRef idx="3">
-            <a:schemeClr val="accent1"/>
-          </a:fillRef>
-          <a:effectRef idx="2">
-            <a:schemeClr val="accent1"/>
-          </a:effectRef>
-          <a:fontRef idx="minor">
-            <a:schemeClr val="lt1"/>
-          </a:fontRef>
-        </p:style>
-        <p:txBody>
-          <a:bodyPr rtlCol="0" anchor="ctr"/>
-          <a:lstStyle/>
-          <a:p>
-            <a:pPr algn="ctr"/>
-            <a:r>
-              <a:rPr sz="1400">
-                <a:solidFill>
-                  <a:srgbClr val="FFFFFF"/>
-                </a:solidFill>
-              </a:rPr>
-              <a:t>✔</a:t>
-            </a:r>
-          </a:p>
-        </p:txBody>
-      </p:sp>
-      <p:sp>
-        <p:nvSpPr>
           <p:cNvPr id="13" name="TextBox 12"/>
           <p:cNvSpPr txBox="1"/>
           <p:nvPr/>
@@ -4687,57 +5227,6 @@
       </p:sp>
       <p:sp>
         <p:nvSpPr>
-          <p:cNvPr id="15" name="Rounded Rectangle 14"/>
-          <p:cNvSpPr/>
-          <p:nvPr/>
-        </p:nvSpPr>
-        <p:spPr>
-          <a:xfrm>
-            <a:off x="731520" y="4572000"/>
-            <a:ext cx="457200" cy="457200"/>
-          </a:xfrm>
-          <a:prstGeom prst="roundRect">
-            <a:avLst/>
-          </a:prstGeom>
-          <a:solidFill>
-            <a:srgbClr val="6B8F3C"/>
-          </a:solidFill>
-          <a:ln>
-            <a:noFill/>
-          </a:ln>
-        </p:spPr>
-        <p:style>
-          <a:lnRef idx="1">
-            <a:schemeClr val="accent1"/>
-          </a:lnRef>
-          <a:fillRef idx="3">
-            <a:schemeClr val="accent1"/>
-          </a:fillRef>
-          <a:effectRef idx="2">
-            <a:schemeClr val="accent1"/>
-          </a:effectRef>
-          <a:fontRef idx="minor">
-            <a:schemeClr val="lt1"/>
-          </a:fontRef>
-        </p:style>
-        <p:txBody>
-          <a:bodyPr rtlCol="0" anchor="ctr"/>
-          <a:lstStyle/>
-          <a:p>
-            <a:pPr algn="ctr"/>
-            <a:r>
-              <a:rPr sz="1400">
-                <a:solidFill>
-                  <a:srgbClr val="FFFFFF"/>
-                </a:solidFill>
-              </a:rPr>
-              <a:t>✔</a:t>
-            </a:r>
-          </a:p>
-        </p:txBody>
-      </p:sp>
-      <p:sp>
-        <p:nvSpPr>
           <p:cNvPr id="16" name="TextBox 15"/>
           <p:cNvSpPr txBox="1"/>
           <p:nvPr/>
@@ -4800,57 +5289,6 @@
                 <a:latin typeface="Arial"/>
               </a:rPr>
               <a:t>You only pay for the leads we deliver — $50 per qualified lead</a:t>
-            </a:r>
-          </a:p>
-        </p:txBody>
-      </p:sp>
-      <p:sp>
-        <p:nvSpPr>
-          <p:cNvPr id="18" name="Rounded Rectangle 17"/>
-          <p:cNvSpPr/>
-          <p:nvPr/>
-        </p:nvSpPr>
-        <p:spPr>
-          <a:xfrm>
-            <a:off x="731520" y="5577840"/>
-            <a:ext cx="457200" cy="457200"/>
-          </a:xfrm>
-          <a:prstGeom prst="roundRect">
-            <a:avLst/>
-          </a:prstGeom>
-          <a:solidFill>
-            <a:srgbClr val="6B8F3C"/>
-          </a:solidFill>
-          <a:ln>
-            <a:noFill/>
-          </a:ln>
-        </p:spPr>
-        <p:style>
-          <a:lnRef idx="1">
-            <a:schemeClr val="accent1"/>
-          </a:lnRef>
-          <a:fillRef idx="3">
-            <a:schemeClr val="accent1"/>
-          </a:fillRef>
-          <a:effectRef idx="2">
-            <a:schemeClr val="accent1"/>
-          </a:effectRef>
-          <a:fontRef idx="minor">
-            <a:schemeClr val="lt1"/>
-          </a:fontRef>
-        </p:style>
-        <p:txBody>
-          <a:bodyPr rtlCol="0" anchor="ctr"/>
-          <a:lstStyle/>
-          <a:p>
-            <a:pPr algn="ctr"/>
-            <a:r>
-              <a:rPr sz="1400">
-                <a:solidFill>
-                  <a:srgbClr val="FFFFFF"/>
-                </a:solidFill>
-              </a:rPr>
-              <a:t>✔</a:t>
             </a:r>
           </a:p>
         </p:txBody>
@@ -4963,6 +5401,7 @@
           <a:lstStyle/>
           <a:p>
             <a:pPr algn="ctr"/>
+            <a:endParaRPr/>
           </a:p>
         </p:txBody>
       </p:sp>
@@ -5205,6 +5644,7 @@
           <a:lstStyle/>
           <a:p>
             <a:pPr algn="ctr"/>
+            <a:endParaRPr/>
           </a:p>
         </p:txBody>
       </p:sp>
@@ -5315,6 +5755,7 @@
           <a:lstStyle/>
           <a:p>
             <a:pPr algn="ctr"/>
+            <a:endParaRPr/>
           </a:p>
         </p:txBody>
       </p:sp>
@@ -5425,6 +5866,7 @@
           <a:lstStyle/>
           <a:p>
             <a:pPr algn="ctr"/>
+            <a:endParaRPr/>
           </a:p>
         </p:txBody>
       </p:sp>
@@ -5495,6 +5937,98 @@
           </a:p>
         </p:txBody>
       </p:sp>
+      <p:pic>
+        <p:nvPicPr>
+          <p:cNvPr id="35" name="Picture 34"/>
+          <p:cNvPicPr>
+            <a:picLocks noChangeAspect="1"/>
+          </p:cNvPicPr>
+          <p:nvPr/>
+        </p:nvPicPr>
+        <p:blipFill>
+          <a:blip r:embed="rId3"/>
+          <a:srcRect/>
+          <a:stretch/>
+        </p:blipFill>
+        <p:spPr>
+          <a:xfrm>
+            <a:off x="731520" y="2560320"/>
+            <a:ext cx="457200" cy="457200"/>
+          </a:xfrm>
+          <a:prstGeom prst="rect">
+            <a:avLst/>
+          </a:prstGeom>
+        </p:spPr>
+      </p:pic>
+      <p:pic>
+        <p:nvPicPr>
+          <p:cNvPr id="36" name="Picture 35"/>
+          <p:cNvPicPr>
+            <a:picLocks noChangeAspect="1"/>
+          </p:cNvPicPr>
+          <p:nvPr/>
+        </p:nvPicPr>
+        <p:blipFill>
+          <a:blip r:embed="rId3"/>
+          <a:srcRect/>
+          <a:stretch/>
+        </p:blipFill>
+        <p:spPr>
+          <a:xfrm>
+            <a:off x="731520" y="3566160"/>
+            <a:ext cx="457200" cy="457200"/>
+          </a:xfrm>
+          <a:prstGeom prst="rect">
+            <a:avLst/>
+          </a:prstGeom>
+        </p:spPr>
+      </p:pic>
+      <p:pic>
+        <p:nvPicPr>
+          <p:cNvPr id="37" name="Picture 36"/>
+          <p:cNvPicPr>
+            <a:picLocks noChangeAspect="1"/>
+          </p:cNvPicPr>
+          <p:nvPr/>
+        </p:nvPicPr>
+        <p:blipFill>
+          <a:blip r:embed="rId3"/>
+          <a:srcRect/>
+          <a:stretch/>
+        </p:blipFill>
+        <p:spPr>
+          <a:xfrm>
+            <a:off x="731520" y="4572000"/>
+            <a:ext cx="457200" cy="457200"/>
+          </a:xfrm>
+          <a:prstGeom prst="rect">
+            <a:avLst/>
+          </a:prstGeom>
+        </p:spPr>
+      </p:pic>
+      <p:pic>
+        <p:nvPicPr>
+          <p:cNvPr id="38" name="Picture 37"/>
+          <p:cNvPicPr>
+            <a:picLocks noChangeAspect="1"/>
+          </p:cNvPicPr>
+          <p:nvPr/>
+        </p:nvPicPr>
+        <p:blipFill>
+          <a:blip r:embed="rId3"/>
+          <a:srcRect/>
+          <a:stretch/>
+        </p:blipFill>
+        <p:spPr>
+          <a:xfrm>
+            <a:off x="731520" y="5577840"/>
+            <a:ext cx="457200" cy="457200"/>
+          </a:xfrm>
+          <a:prstGeom prst="rect">
+            <a:avLst/>
+          </a:prstGeom>
+        </p:spPr>
+      </p:pic>
     </p:spTree>
   </p:cSld>
   <p:clrMapOvr>
@@ -5504,7 +6038,7 @@
 </file>
 
 <file path=ppt/slides/slide4.xml><?xml version="1.0" encoding="utf-8"?>
-<p:sld xmlns:a="http://schemas.openxmlformats.org/drawingml/2006/main" xmlns:p="http://schemas.openxmlformats.org/presentationml/2006/main" xmlns:r="http://schemas.openxmlformats.org/officeDocument/2006/relationships">
+<p:sld xmlns:a="http://schemas.openxmlformats.org/drawingml/2006/main" xmlns:r="http://schemas.openxmlformats.org/officeDocument/2006/relationships" xmlns:p="http://schemas.openxmlformats.org/presentationml/2006/main">
   <p:cSld>
     <p:spTree>
       <p:nvGrpSpPr>
@@ -5512,7 +6046,14 @@
         <p:cNvGrpSpPr/>
         <p:nvPr/>
       </p:nvGrpSpPr>
-      <p:grpSpPr/>
+      <p:grpSpPr>
+        <a:xfrm>
+          <a:off x="0" y="0"/>
+          <a:ext cx="0" cy="0"/>
+          <a:chOff x="0" y="0"/>
+          <a:chExt cx="0" cy="0"/>
+        </a:xfrm>
+      </p:grpSpPr>
       <p:sp>
         <p:nvSpPr>
           <p:cNvPr id="2" name="Rectangle 1"/>
@@ -5553,6 +6094,7 @@
           <a:lstStyle/>
           <a:p>
             <a:pPr algn="ctr"/>
+            <a:endParaRPr/>
           </a:p>
         </p:txBody>
       </p:sp>
@@ -5596,6 +6138,7 @@
           <a:lstStyle/>
           <a:p>
             <a:pPr algn="ctr"/>
+            <a:endParaRPr/>
           </a:p>
         </p:txBody>
       </p:sp>
@@ -5675,6 +6218,7 @@
           <a:lstStyle/>
           <a:p>
             <a:pPr algn="ctr"/>
+            <a:endParaRPr/>
           </a:p>
         </p:txBody>
       </p:sp>
@@ -5778,6 +6322,7 @@
           <a:lstStyle/>
           <a:p>
             <a:pPr algn="ctr"/>
+            <a:endParaRPr/>
           </a:p>
         </p:txBody>
       </p:sp>
@@ -5902,6 +6447,7 @@
           <a:lstStyle/>
           <a:p>
             <a:pPr algn="ctr"/>
+            <a:endParaRPr/>
           </a:p>
         </p:txBody>
       </p:sp>
@@ -6241,6 +6787,7 @@
           <a:lstStyle/>
           <a:p>
             <a:pPr algn="ctr"/>
+            <a:endParaRPr/>
           </a:p>
         </p:txBody>
       </p:sp>
@@ -6287,8 +6834,8 @@
         </p:nvSpPr>
         <p:spPr>
           <a:xfrm>
-            <a:off x="4663440" y="2286000"/>
-            <a:ext cx="3017520" cy="822960"/>
+            <a:off x="5222261" y="2286000"/>
+            <a:ext cx="1899880" cy="907941"/>
           </a:xfrm>
           <a:prstGeom prst="rect">
             <a:avLst/>
@@ -6303,19 +6850,46 @@
           <a:p>
             <a:pPr algn="ctr"/>
             <a:r>
-              <a:rPr sz="4000" b="1">
+              <a:rPr sz="4000" b="1" dirty="0">
                 <a:solidFill>
                   <a:srgbClr val="1A1A1A"/>
                 </a:solidFill>
                 <a:latin typeface="Georgia"/>
               </a:rPr>
-              <a:t>$200</a:t>
+              <a:t>$</a:t>
+            </a:r>
+            <a:r>
+              <a:rPr lang="da-DK" sz="4000" b="1" dirty="0">
+                <a:solidFill>
+                  <a:srgbClr val="1A1A1A"/>
+                </a:solidFill>
+                <a:latin typeface="Georgia"/>
+              </a:rPr>
+              <a:t>80</a:t>
+            </a:r>
+            <a:r>
+              <a:rPr sz="4000" b="1" dirty="0">
+                <a:solidFill>
+                  <a:srgbClr val="1A1A1A"/>
+                </a:solidFill>
+                <a:latin typeface="Georgia"/>
+              </a:rPr>
+              <a:t>0</a:t>
             </a:r>
           </a:p>
           <a:p>
             <a:pPr algn="ctr"/>
             <a:r>
-              <a:rPr sz="1300">
+              <a:rPr lang="da-DK" sz="1300" dirty="0">
+                <a:solidFill>
+                  <a:srgbClr val="555555"/>
+                </a:solidFill>
+                <a:latin typeface="Arial"/>
+              </a:rPr>
+              <a:t>$133</a:t>
+            </a:r>
+            <a:r>
+              <a:rPr sz="1300" dirty="0">
                 <a:solidFill>
                   <a:srgbClr val="555555"/>
                 </a:solidFill>
@@ -6366,6 +6940,7 @@
           <a:lstStyle/>
           <a:p>
             <a:pPr algn="ctr"/>
+            <a:endParaRPr/>
           </a:p>
         </p:txBody>
       </p:sp>
@@ -6663,6 +7238,7 @@
           <a:lstStyle/>
           <a:p>
             <a:pPr algn="ctr"/>
+            <a:endParaRPr/>
           </a:p>
         </p:txBody>
       </p:sp>
@@ -6761,8 +7337,8 @@
         </p:nvSpPr>
         <p:spPr>
           <a:xfrm>
-            <a:off x="8595360" y="2286000"/>
-            <a:ext cx="3017520" cy="822960"/>
+            <a:off x="9183035" y="2286000"/>
+            <a:ext cx="1842172" cy="907941"/>
           </a:xfrm>
           <a:prstGeom prst="rect">
             <a:avLst/>
@@ -6777,25 +7353,70 @@
           <a:p>
             <a:pPr algn="ctr"/>
             <a:r>
-              <a:rPr sz="4000" b="1">
+              <a:rPr sz="4000" b="1" dirty="0">
                 <a:solidFill>
                   <a:srgbClr val="1A1A1A"/>
                 </a:solidFill>
                 <a:latin typeface="Georgia"/>
               </a:rPr>
-              <a:t>$300</a:t>
+              <a:t>$</a:t>
+            </a:r>
+            <a:r>
+              <a:rPr lang="da-DK" sz="4000" b="1" dirty="0">
+                <a:solidFill>
+                  <a:srgbClr val="1A1A1A"/>
+                </a:solidFill>
+                <a:latin typeface="Georgia"/>
+              </a:rPr>
+              <a:t>10</a:t>
+            </a:r>
+            <a:r>
+              <a:rPr sz="4000" b="1" dirty="0">
+                <a:solidFill>
+                  <a:srgbClr val="1A1A1A"/>
+                </a:solidFill>
+                <a:latin typeface="Georgia"/>
+              </a:rPr>
+              <a:t>00</a:t>
             </a:r>
           </a:p>
           <a:p>
             <a:pPr algn="ctr"/>
             <a:r>
-              <a:rPr sz="1300">
+              <a:rPr lang="da-DK" sz="1300" dirty="0">
                 <a:solidFill>
                   <a:srgbClr val="555555"/>
                 </a:solidFill>
                 <a:latin typeface="Arial"/>
               </a:rPr>
-              <a:t>/month + $50/lead</a:t>
+              <a:t>$83</a:t>
+            </a:r>
+            <a:r>
+              <a:rPr sz="1300" dirty="0">
+                <a:solidFill>
+                  <a:srgbClr val="555555"/>
+                </a:solidFill>
+                <a:latin typeface="Arial"/>
+              </a:rPr>
+              <a:t>/</a:t>
+            </a:r>
+            <a:r>
+              <a:rPr lang="da-DK" sz="1300" dirty="0" err="1">
+                <a:solidFill>
+                  <a:srgbClr val="555555"/>
+                </a:solidFill>
+                <a:latin typeface="Arial"/>
+              </a:rPr>
+              <a:t>month</a:t>
+            </a:r>
+            <a:r>
+              <a:rPr sz="1300" dirty="0">
+                <a:solidFill>
+                  <a:srgbClr val="555555"/>
+                </a:solidFill>
+                <a:latin typeface="Arial"/>
+              </a:rPr>
+              <a:t> + $50/lead</a:t>
             </a:r>
           </a:p>
         </p:txBody>
@@ -6840,6 +7461,7 @@
           <a:lstStyle/>
           <a:p>
             <a:pPr algn="ctr"/>
+            <a:endParaRPr/>
           </a:p>
         </p:txBody>
       </p:sp>
@@ -6908,7 +7530,7 @@
           <a:lstStyle/>
           <a:p>
             <a:r>
-              <a:rPr sz="1200">
+              <a:rPr sz="1200" dirty="0">
                 <a:solidFill>
                   <a:srgbClr val="6B8F3C"/>
                 </a:solidFill>
@@ -6916,7 +7538,7 @@
               <a:t>✔  </a:t>
             </a:r>
             <a:r>
-              <a:rPr sz="1200">
+              <a:rPr sz="1200" dirty="0">
                 <a:solidFill>
                   <a:srgbClr val="333333"/>
                 </a:solidFill>
@@ -7089,7 +7711,7 @@
           </a:fontRef>
         </p:style>
         <p:txBody>
-          <a:bodyPr rtlCol="0" anchor="ctr" wrap="square"/>
+          <a:bodyPr wrap="square" rtlCol="0" anchor="ctr"/>
           <a:lstStyle/>
           <a:p>
             <a:pPr algn="ctr">

</xml_diff>